<commit_message>
Add 'Two evolution engines' slide after the self-evolution slide
Inserted via python-pptx (add_evolution.py) into the hand-edited
0604-v2 decks, after the self-evolution slide (located by its unique
kicker to avoid the cover subtitle / summary which also mention
自我进化/Hermes). Two lanes: Loop A (AI investigation → Legal review →
update playbook, + feedback) and Loop B (agent mines candidates → PPV
calibration → human approval → new rule, + gate note).

Co-Authored-By: Claude Opus 4.8 (1M context) <noreply@anthropic.com>
</commit_message>
<xml_diff>
--- a/ppt/AML-System-Walkthrough-Legal-CN-0604-v2.pptx
+++ b/ppt/AML-System-Walkthrough-Legal-CN-0604-v2.pptx
@@ -16,6 +16,7 @@
     <p:sldId id="260" r:id="rId6"/>
     <p:sldId id="261" r:id="rId7"/>
     <p:sldId id="263" r:id="rId8"/>
+    <p:sldId id="266" r:id="rId16"/>
     <p:sldId id="264" r:id="rId9"/>
   </p:sldIdLst>
   <p:sldSz cx="12192000" cy="6858000"/>
@@ -1527,7 +1528,2181 @@
 </p:sld>
 </file>
 
+<file path=ppt/slides/slide10.xml><?xml version="1.0" encoding="utf-8"?>
+<p:sld xmlns:a="http://schemas.openxmlformats.org/drawingml/2006/main" xmlns:p="http://schemas.openxmlformats.org/presentationml/2006/main" xmlns:r="http://schemas.openxmlformats.org/officeDocument/2006/relationships">
+  <p:cSld>
+    <p:bg>
+      <p:bgPr>
+        <a:solidFill>
+          <a:srgbClr val="FFFFFF"/>
+        </a:solidFill>
+        <a:effectLst/>
+      </p:bgPr>
+    </p:bg>
+    <p:spTree>
+      <p:nvGrpSpPr>
+        <p:cNvPr id="1" name=""/>
+        <p:cNvGrpSpPr/>
+        <p:nvPr/>
+      </p:nvGrpSpPr>
+      <p:grpSpPr/>
+      <p:sp>
+        <p:nvSpPr>
+          <p:cNvPr id="2" name="Rectangle 1"/>
+          <p:cNvSpPr/>
+          <p:nvPr/>
+        </p:nvSpPr>
+        <p:spPr>
+          <a:xfrm>
+            <a:off x="0" y="0"/>
+            <a:ext cx="256032" cy="6858000"/>
+          </a:xfrm>
+          <a:prstGeom prst="rect">
+            <a:avLst/>
+          </a:prstGeom>
+          <a:solidFill>
+            <a:srgbClr val="1BA39C"/>
+          </a:solidFill>
+          <a:ln>
+            <a:noFill/>
+          </a:ln>
+          <a:effectLst/>
+        </p:spPr>
+        <p:style>
+          <a:lnRef idx="1">
+            <a:schemeClr val="accent1"/>
+          </a:lnRef>
+          <a:fillRef idx="3">
+            <a:schemeClr val="accent1"/>
+          </a:fillRef>
+          <a:effectRef idx="2">
+            <a:schemeClr val="accent1"/>
+          </a:effectRef>
+          <a:fontRef idx="minor">
+            <a:schemeClr val="lt1"/>
+          </a:fontRef>
+        </p:style>
+        <p:txBody>
+          <a:bodyPr rtlCol="0" anchor="ctr"/>
+          <a:lstStyle/>
+          <a:p>
+            <a:pPr algn="ctr"/>
+          </a:p>
+        </p:txBody>
+      </p:sp>
+      <p:sp>
+        <p:nvSpPr>
+          <p:cNvPr id="3" name="TextBox 2"/>
+          <p:cNvSpPr txBox="1"/>
+          <p:nvPr/>
+        </p:nvSpPr>
+        <p:spPr>
+          <a:xfrm>
+            <a:off x="548640" y="457200"/>
+            <a:ext cx="9144000" cy="274320"/>
+          </a:xfrm>
+          <a:prstGeom prst="rect">
+            <a:avLst/>
+          </a:prstGeom>
+          <a:noFill/>
+        </p:spPr>
+        <p:txBody>
+          <a:bodyPr wrap="square" anchor="t" lIns="36576" rIns="36576" tIns="18288" bIns="18288">
+            <a:spAutoFit/>
+          </a:bodyPr>
+          <a:lstStyle/>
+          <a:p>
+            <a:pPr algn="l">
+              <a:lnSpc>
+                <a:spcPct val="105000"/>
+              </a:lnSpc>
+            </a:pPr>
+            <a:r>
+              <a:rPr sz="1200" b="1">
+                <a:solidFill>
+                  <a:srgbClr val="1BA39C"/>
+                </a:solidFill>
+                <a:latin typeface="Microsoft YaHei"/>
+              </a:rPr>
+              <a:t>进化机制</a:t>
+            </a:r>
+          </a:p>
+        </p:txBody>
+      </p:sp>
+      <p:sp>
+        <p:nvSpPr>
+          <p:cNvPr id="4" name="TextBox 3"/>
+          <p:cNvSpPr txBox="1"/>
+          <p:nvPr/>
+        </p:nvSpPr>
+        <p:spPr>
+          <a:xfrm>
+            <a:off x="548640" y="749808"/>
+            <a:ext cx="11064240" cy="822960"/>
+          </a:xfrm>
+          <a:prstGeom prst="rect">
+            <a:avLst/>
+          </a:prstGeom>
+          <a:noFill/>
+        </p:spPr>
+        <p:txBody>
+          <a:bodyPr wrap="square" anchor="t" lIns="36576" rIns="36576" tIns="18288" bIns="18288">
+            <a:spAutoFit/>
+          </a:bodyPr>
+          <a:lstStyle/>
+          <a:p>
+            <a:pPr algn="l">
+              <a:lnSpc>
+                <a:spcPct val="105000"/>
+              </a:lnSpc>
+            </a:pPr>
+            <a:r>
+              <a:rPr sz="3000" b="1">
+                <a:solidFill>
+                  <a:srgbClr val="17313F"/>
+                </a:solidFill>
+                <a:latin typeface="Microsoft YaHei"/>
+              </a:rPr>
+              <a:t>两套进化引擎</a:t>
+            </a:r>
+          </a:p>
+        </p:txBody>
+      </p:sp>
+      <p:sp>
+        <p:nvSpPr>
+          <p:cNvPr id="5" name="TextBox 4"/>
+          <p:cNvSpPr txBox="1"/>
+          <p:nvPr/>
+        </p:nvSpPr>
+        <p:spPr>
+          <a:xfrm>
+            <a:off x="566928" y="1600200"/>
+            <a:ext cx="10972800" cy="457200"/>
+          </a:xfrm>
+          <a:prstGeom prst="rect">
+            <a:avLst/>
+          </a:prstGeom>
+          <a:noFill/>
+        </p:spPr>
+        <p:txBody>
+          <a:bodyPr wrap="square" anchor="t" lIns="36576" rIns="36576" tIns="18288" bIns="18288">
+            <a:spAutoFit/>
+          </a:bodyPr>
+          <a:lstStyle/>
+          <a:p>
+            <a:pPr algn="l">
+              <a:lnSpc>
+                <a:spcPct val="115000"/>
+              </a:lnSpc>
+            </a:pPr>
+            <a:r>
+              <a:rPr sz="1400" b="0">
+                <a:solidFill>
+                  <a:srgbClr val="71838F"/>
+                </a:solidFill>
+                <a:latin typeface="Microsoft YaHei"/>
+              </a:rPr>
+              <a:t>系统在两个方向上持续进化，但都受可审计闸门约束。</a:t>
+            </a:r>
+          </a:p>
+        </p:txBody>
+      </p:sp>
+      <p:sp>
+        <p:nvSpPr>
+          <p:cNvPr id="6" name="TextBox 5"/>
+          <p:cNvSpPr txBox="1"/>
+          <p:nvPr/>
+        </p:nvSpPr>
+        <p:spPr>
+          <a:xfrm>
+            <a:off x="640080" y="2148840"/>
+            <a:ext cx="10058400" cy="292608"/>
+          </a:xfrm>
+          <a:prstGeom prst="rect">
+            <a:avLst/>
+          </a:prstGeom>
+          <a:noFill/>
+        </p:spPr>
+        <p:txBody>
+          <a:bodyPr wrap="square" anchor="t" lIns="36576" rIns="36576" tIns="18288" bIns="18288">
+            <a:spAutoFit/>
+          </a:bodyPr>
+          <a:lstStyle/>
+          <a:p>
+            <a:pPr algn="l">
+              <a:lnSpc>
+                <a:spcPct val="105000"/>
+              </a:lnSpc>
+            </a:pPr>
+            <a:r>
+              <a:rPr sz="1300" b="1">
+                <a:solidFill>
+                  <a:srgbClr val="1BA39C"/>
+                </a:solidFill>
+                <a:latin typeface="Microsoft YaHei"/>
+              </a:rPr>
+              <a:t>进化 A · 调查越查越准 / 越全</a:t>
+            </a:r>
+          </a:p>
+        </p:txBody>
+      </p:sp>
+      <p:sp>
+        <p:nvSpPr>
+          <p:cNvPr id="7" name="Rounded Rectangle 6"/>
+          <p:cNvSpPr/>
+          <p:nvPr/>
+        </p:nvSpPr>
+        <p:spPr>
+          <a:xfrm>
+            <a:off x="640080" y="2487168"/>
+            <a:ext cx="3291840" cy="822960"/>
+          </a:xfrm>
+          <a:prstGeom prst="roundRect">
+            <a:avLst>
+              <a:gd name="adj" fmla="val 12000"/>
+            </a:avLst>
+          </a:prstGeom>
+          <a:solidFill>
+            <a:srgbClr val="F4FAFB"/>
+          </a:solidFill>
+          <a:ln w="12700">
+            <a:solidFill>
+              <a:srgbClr val="DCE8EE"/>
+            </a:solidFill>
+          </a:ln>
+          <a:effectLst/>
+        </p:spPr>
+        <p:style>
+          <a:lnRef idx="1">
+            <a:schemeClr val="accent1"/>
+          </a:lnRef>
+          <a:fillRef idx="3">
+            <a:schemeClr val="accent1"/>
+          </a:fillRef>
+          <a:effectRef idx="2">
+            <a:schemeClr val="accent1"/>
+          </a:effectRef>
+          <a:fontRef idx="minor">
+            <a:schemeClr val="lt1"/>
+          </a:fontRef>
+        </p:style>
+        <p:txBody>
+          <a:bodyPr rtlCol="0" anchor="ctr"/>
+          <a:lstStyle/>
+          <a:p>
+            <a:pPr algn="ctr"/>
+          </a:p>
+        </p:txBody>
+      </p:sp>
+      <p:sp>
+        <p:nvSpPr>
+          <p:cNvPr id="8" name="TextBox 7"/>
+          <p:cNvSpPr txBox="1"/>
+          <p:nvPr/>
+        </p:nvSpPr>
+        <p:spPr>
+          <a:xfrm>
+            <a:off x="694944" y="2487168"/>
+            <a:ext cx="3182112" cy="822960"/>
+          </a:xfrm>
+          <a:prstGeom prst="rect">
+            <a:avLst/>
+          </a:prstGeom>
+          <a:noFill/>
+        </p:spPr>
+        <p:txBody>
+          <a:bodyPr wrap="square" anchor="ctr" lIns="36576" rIns="36576" tIns="18288" bIns="18288">
+            <a:spAutoFit/>
+          </a:bodyPr>
+          <a:lstStyle/>
+          <a:p>
+            <a:pPr algn="ctr">
+              <a:lnSpc>
+                <a:spcPct val="100000"/>
+              </a:lnSpc>
+            </a:pPr>
+            <a:r>
+              <a:rPr sz="1250" b="1">
+                <a:solidFill>
+                  <a:srgbClr val="17313F"/>
+                </a:solidFill>
+                <a:latin typeface="Microsoft YaHei"/>
+              </a:rPr>
+              <a:t>AI 调查</a:t>
+            </a:r>
+          </a:p>
+        </p:txBody>
+      </p:sp>
+      <p:sp>
+        <p:nvSpPr>
+          <p:cNvPr id="9" name="TextBox 8"/>
+          <p:cNvSpPr txBox="1"/>
+          <p:nvPr/>
+        </p:nvSpPr>
+        <p:spPr>
+          <a:xfrm>
+            <a:off x="3950207" y="2697480"/>
+            <a:ext cx="384048" cy="402336"/>
+          </a:xfrm>
+          <a:prstGeom prst="rect">
+            <a:avLst/>
+          </a:prstGeom>
+          <a:noFill/>
+        </p:spPr>
+        <p:txBody>
+          <a:bodyPr wrap="square" anchor="ctr" lIns="36576" rIns="36576" tIns="18288" bIns="18288">
+            <a:spAutoFit/>
+          </a:bodyPr>
+          <a:lstStyle/>
+          <a:p>
+            <a:pPr algn="ctr">
+              <a:lnSpc>
+                <a:spcPct val="105000"/>
+              </a:lnSpc>
+            </a:pPr>
+            <a:r>
+              <a:rPr sz="2000" b="1">
+                <a:solidFill>
+                  <a:srgbClr val="9FB6C0"/>
+                </a:solidFill>
+                <a:latin typeface="Microsoft YaHei"/>
+              </a:rPr>
+              <a:t>→</a:t>
+            </a:r>
+          </a:p>
+        </p:txBody>
+      </p:sp>
+      <p:sp>
+        <p:nvSpPr>
+          <p:cNvPr id="10" name="Rounded Rectangle 9"/>
+          <p:cNvSpPr/>
+          <p:nvPr/>
+        </p:nvSpPr>
+        <p:spPr>
+          <a:xfrm>
+            <a:off x="4343400" y="2487168"/>
+            <a:ext cx="3291840" cy="822960"/>
+          </a:xfrm>
+          <a:prstGeom prst="roundRect">
+            <a:avLst>
+              <a:gd name="adj" fmla="val 12000"/>
+            </a:avLst>
+          </a:prstGeom>
+          <a:solidFill>
+            <a:srgbClr val="F4FAFB"/>
+          </a:solidFill>
+          <a:ln w="12700">
+            <a:solidFill>
+              <a:srgbClr val="DCE8EE"/>
+            </a:solidFill>
+          </a:ln>
+          <a:effectLst/>
+        </p:spPr>
+        <p:style>
+          <a:lnRef idx="1">
+            <a:schemeClr val="accent1"/>
+          </a:lnRef>
+          <a:fillRef idx="3">
+            <a:schemeClr val="accent1"/>
+          </a:fillRef>
+          <a:effectRef idx="2">
+            <a:schemeClr val="accent1"/>
+          </a:effectRef>
+          <a:fontRef idx="minor">
+            <a:schemeClr val="lt1"/>
+          </a:fontRef>
+        </p:style>
+        <p:txBody>
+          <a:bodyPr rtlCol="0" anchor="ctr"/>
+          <a:lstStyle/>
+          <a:p>
+            <a:pPr algn="ctr"/>
+          </a:p>
+        </p:txBody>
+      </p:sp>
+      <p:sp>
+        <p:nvSpPr>
+          <p:cNvPr id="11" name="TextBox 10"/>
+          <p:cNvSpPr txBox="1"/>
+          <p:nvPr/>
+        </p:nvSpPr>
+        <p:spPr>
+          <a:xfrm>
+            <a:off x="4398264" y="2487168"/>
+            <a:ext cx="3182112" cy="822960"/>
+          </a:xfrm>
+          <a:prstGeom prst="rect">
+            <a:avLst/>
+          </a:prstGeom>
+          <a:noFill/>
+        </p:spPr>
+        <p:txBody>
+          <a:bodyPr wrap="square" anchor="ctr" lIns="36576" rIns="36576" tIns="18288" bIns="18288">
+            <a:spAutoFit/>
+          </a:bodyPr>
+          <a:lstStyle/>
+          <a:p>
+            <a:pPr algn="ctr">
+              <a:lnSpc>
+                <a:spcPct val="100000"/>
+              </a:lnSpc>
+            </a:pPr>
+            <a:r>
+              <a:rPr sz="1250" b="1">
+                <a:solidFill>
+                  <a:srgbClr val="17313F"/>
+                </a:solidFill>
+                <a:latin typeface="Microsoft YaHei"/>
+              </a:rPr>
+              <a:t>法务复核</a:t>
+            </a:r>
+          </a:p>
+        </p:txBody>
+      </p:sp>
+      <p:sp>
+        <p:nvSpPr>
+          <p:cNvPr id="12" name="TextBox 11"/>
+          <p:cNvSpPr txBox="1"/>
+          <p:nvPr/>
+        </p:nvSpPr>
+        <p:spPr>
+          <a:xfrm>
+            <a:off x="7653527" y="2697480"/>
+            <a:ext cx="384048" cy="402336"/>
+          </a:xfrm>
+          <a:prstGeom prst="rect">
+            <a:avLst/>
+          </a:prstGeom>
+          <a:noFill/>
+        </p:spPr>
+        <p:txBody>
+          <a:bodyPr wrap="square" anchor="ctr" lIns="36576" rIns="36576" tIns="18288" bIns="18288">
+            <a:spAutoFit/>
+          </a:bodyPr>
+          <a:lstStyle/>
+          <a:p>
+            <a:pPr algn="ctr">
+              <a:lnSpc>
+                <a:spcPct val="105000"/>
+              </a:lnSpc>
+            </a:pPr>
+            <a:r>
+              <a:rPr sz="2000" b="1">
+                <a:solidFill>
+                  <a:srgbClr val="9FB6C0"/>
+                </a:solidFill>
+                <a:latin typeface="Microsoft YaHei"/>
+              </a:rPr>
+              <a:t>→</a:t>
+            </a:r>
+          </a:p>
+        </p:txBody>
+      </p:sp>
+      <p:sp>
+        <p:nvSpPr>
+          <p:cNvPr id="13" name="Rounded Rectangle 12"/>
+          <p:cNvSpPr/>
+          <p:nvPr/>
+        </p:nvSpPr>
+        <p:spPr>
+          <a:xfrm>
+            <a:off x="8046719" y="2487168"/>
+            <a:ext cx="3291840" cy="822960"/>
+          </a:xfrm>
+          <a:prstGeom prst="roundRect">
+            <a:avLst>
+              <a:gd name="adj" fmla="val 12000"/>
+            </a:avLst>
+          </a:prstGeom>
+          <a:solidFill>
+            <a:srgbClr val="F4FAFB"/>
+          </a:solidFill>
+          <a:ln w="12700">
+            <a:solidFill>
+              <a:srgbClr val="DCE8EE"/>
+            </a:solidFill>
+          </a:ln>
+          <a:effectLst/>
+        </p:spPr>
+        <p:style>
+          <a:lnRef idx="1">
+            <a:schemeClr val="accent1"/>
+          </a:lnRef>
+          <a:fillRef idx="3">
+            <a:schemeClr val="accent1"/>
+          </a:fillRef>
+          <a:effectRef idx="2">
+            <a:schemeClr val="accent1"/>
+          </a:effectRef>
+          <a:fontRef idx="minor">
+            <a:schemeClr val="lt1"/>
+          </a:fontRef>
+        </p:style>
+        <p:txBody>
+          <a:bodyPr rtlCol="0" anchor="ctr"/>
+          <a:lstStyle/>
+          <a:p>
+            <a:pPr algn="ctr"/>
+          </a:p>
+        </p:txBody>
+      </p:sp>
+      <p:sp>
+        <p:nvSpPr>
+          <p:cNvPr id="14" name="TextBox 13"/>
+          <p:cNvSpPr txBox="1"/>
+          <p:nvPr/>
+        </p:nvSpPr>
+        <p:spPr>
+          <a:xfrm>
+            <a:off x="8101583" y="2487168"/>
+            <a:ext cx="3182112" cy="822960"/>
+          </a:xfrm>
+          <a:prstGeom prst="rect">
+            <a:avLst/>
+          </a:prstGeom>
+          <a:noFill/>
+        </p:spPr>
+        <p:txBody>
+          <a:bodyPr wrap="square" anchor="ctr" lIns="36576" rIns="36576" tIns="18288" bIns="18288">
+            <a:spAutoFit/>
+          </a:bodyPr>
+          <a:lstStyle/>
+          <a:p>
+            <a:pPr algn="ctr">
+              <a:lnSpc>
+                <a:spcPct val="100000"/>
+              </a:lnSpc>
+            </a:pPr>
+            <a:r>
+              <a:rPr sz="1250" b="1">
+                <a:solidFill>
+                  <a:srgbClr val="17313F"/>
+                </a:solidFill>
+                <a:latin typeface="Microsoft YaHei"/>
+              </a:rPr>
+              <a:t>沉淀调查 Playbook</a:t>
+            </a:r>
+          </a:p>
+        </p:txBody>
+      </p:sp>
+      <p:sp>
+        <p:nvSpPr>
+          <p:cNvPr id="15" name="Rounded Rectangle 14"/>
+          <p:cNvSpPr/>
+          <p:nvPr/>
+        </p:nvSpPr>
+        <p:spPr>
+          <a:xfrm>
+            <a:off x="548640" y="3419856"/>
+            <a:ext cx="11091672" cy="566928"/>
+          </a:xfrm>
+          <a:prstGeom prst="roundRect">
+            <a:avLst>
+              <a:gd name="adj" fmla="val 18000"/>
+            </a:avLst>
+          </a:prstGeom>
+          <a:solidFill>
+            <a:srgbClr val="F4FAFB"/>
+          </a:solidFill>
+          <a:ln w="15240">
+            <a:solidFill>
+              <a:srgbClr val="1BA39C"/>
+            </a:solidFill>
+            <a:prstDash val="dash"/>
+          </a:ln>
+          <a:effectLst/>
+        </p:spPr>
+        <p:style>
+          <a:lnRef idx="1">
+            <a:schemeClr val="accent1"/>
+          </a:lnRef>
+          <a:fillRef idx="3">
+            <a:schemeClr val="accent1"/>
+          </a:fillRef>
+          <a:effectRef idx="2">
+            <a:schemeClr val="accent1"/>
+          </a:effectRef>
+          <a:fontRef idx="minor">
+            <a:schemeClr val="lt1"/>
+          </a:fontRef>
+        </p:style>
+        <p:txBody>
+          <a:bodyPr rtlCol="0" anchor="ctr"/>
+          <a:lstStyle/>
+          <a:p>
+            <a:pPr algn="ctr"/>
+          </a:p>
+        </p:txBody>
+      </p:sp>
+      <p:sp>
+        <p:nvSpPr>
+          <p:cNvPr id="16" name="TextBox 15"/>
+          <p:cNvSpPr txBox="1"/>
+          <p:nvPr/>
+        </p:nvSpPr>
+        <p:spPr>
+          <a:xfrm>
+            <a:off x="868680" y="3419856"/>
+            <a:ext cx="10515600" cy="566928"/>
+          </a:xfrm>
+          <a:prstGeom prst="rect">
+            <a:avLst/>
+          </a:prstGeom>
+          <a:noFill/>
+        </p:spPr>
+        <p:txBody>
+          <a:bodyPr wrap="square" anchor="ctr" lIns="36576" rIns="36576" tIns="18288" bIns="18288">
+            <a:spAutoFit/>
+          </a:bodyPr>
+          <a:lstStyle/>
+          <a:p>
+            <a:pPr algn="l">
+              <a:lnSpc>
+                <a:spcPct val="105000"/>
+              </a:lnSpc>
+            </a:pPr>
+            <a:r>
+              <a:rPr sz="1250" b="1">
+                <a:solidFill>
+                  <a:srgbClr val="1BA39C"/>
+                </a:solidFill>
+                <a:latin typeface="Microsoft YaHei"/>
+              </a:rPr>
+              <a:t>回流：</a:t>
+            </a:r>
+            <a:r>
+              <a:rPr sz="1250" b="0">
+                <a:solidFill>
+                  <a:srgbClr val="17313F"/>
+                </a:solidFill>
+                <a:latin typeface="Microsoft YaHei"/>
+              </a:rPr>
+              <a:t>每次复核的「漏了什么 / 查错了什么」沉淀成调查套路，下次查得更准、更全。</a:t>
+            </a:r>
+          </a:p>
+        </p:txBody>
+      </p:sp>
+      <p:sp>
+        <p:nvSpPr>
+          <p:cNvPr id="17" name="TextBox 16"/>
+          <p:cNvSpPr txBox="1"/>
+          <p:nvPr/>
+        </p:nvSpPr>
+        <p:spPr>
+          <a:xfrm>
+            <a:off x="685800" y="4224528"/>
+            <a:ext cx="10058400" cy="292608"/>
+          </a:xfrm>
+          <a:prstGeom prst="rect">
+            <a:avLst/>
+          </a:prstGeom>
+          <a:noFill/>
+        </p:spPr>
+        <p:txBody>
+          <a:bodyPr wrap="square" anchor="t" lIns="36576" rIns="36576" tIns="18288" bIns="18288">
+            <a:spAutoFit/>
+          </a:bodyPr>
+          <a:lstStyle/>
+          <a:p>
+            <a:pPr algn="l">
+              <a:lnSpc>
+                <a:spcPct val="105000"/>
+              </a:lnSpc>
+            </a:pPr>
+            <a:r>
+              <a:rPr sz="1300" b="1">
+                <a:solidFill>
+                  <a:srgbClr val="C9861A"/>
+                </a:solidFill>
+                <a:latin typeface="Microsoft YaHei"/>
+              </a:rPr>
+              <a:t>进化 B · 不断发现新 T1 / T2 规则</a:t>
+            </a:r>
+          </a:p>
+        </p:txBody>
+      </p:sp>
+      <p:sp>
+        <p:nvSpPr>
+          <p:cNvPr id="18" name="Rounded Rectangle 17"/>
+          <p:cNvSpPr/>
+          <p:nvPr/>
+        </p:nvSpPr>
+        <p:spPr>
+          <a:xfrm>
+            <a:off x="685800" y="4562856"/>
+            <a:ext cx="2331720" cy="822960"/>
+          </a:xfrm>
+          <a:prstGeom prst="roundRect">
+            <a:avLst>
+              <a:gd name="adj" fmla="val 12000"/>
+            </a:avLst>
+          </a:prstGeom>
+          <a:solidFill>
+            <a:srgbClr val="F4FAFB"/>
+          </a:solidFill>
+          <a:ln w="12700">
+            <a:solidFill>
+              <a:srgbClr val="DCE8EE"/>
+            </a:solidFill>
+          </a:ln>
+          <a:effectLst/>
+        </p:spPr>
+        <p:style>
+          <a:lnRef idx="1">
+            <a:schemeClr val="accent1"/>
+          </a:lnRef>
+          <a:fillRef idx="3">
+            <a:schemeClr val="accent1"/>
+          </a:fillRef>
+          <a:effectRef idx="2">
+            <a:schemeClr val="accent1"/>
+          </a:effectRef>
+          <a:fontRef idx="minor">
+            <a:schemeClr val="lt1"/>
+          </a:fontRef>
+        </p:style>
+        <p:txBody>
+          <a:bodyPr rtlCol="0" anchor="ctr"/>
+          <a:lstStyle/>
+          <a:p>
+            <a:pPr algn="ctr"/>
+          </a:p>
+        </p:txBody>
+      </p:sp>
+      <p:sp>
+        <p:nvSpPr>
+          <p:cNvPr id="19" name="TextBox 18"/>
+          <p:cNvSpPr txBox="1"/>
+          <p:nvPr/>
+        </p:nvSpPr>
+        <p:spPr>
+          <a:xfrm>
+            <a:off x="740664" y="4562856"/>
+            <a:ext cx="2221991" cy="822960"/>
+          </a:xfrm>
+          <a:prstGeom prst="rect">
+            <a:avLst/>
+          </a:prstGeom>
+          <a:noFill/>
+        </p:spPr>
+        <p:txBody>
+          <a:bodyPr wrap="square" anchor="ctr" lIns="36576" rIns="36576" tIns="18288" bIns="18288">
+            <a:spAutoFit/>
+          </a:bodyPr>
+          <a:lstStyle/>
+          <a:p>
+            <a:pPr algn="ctr">
+              <a:lnSpc>
+                <a:spcPct val="100000"/>
+              </a:lnSpc>
+            </a:pPr>
+            <a:r>
+              <a:rPr sz="1250" b="1">
+                <a:solidFill>
+                  <a:srgbClr val="17313F"/>
+                </a:solidFill>
+                <a:latin typeface="Microsoft YaHei"/>
+              </a:rPr>
+              <a:t>Agent 挖候选信号</a:t>
+            </a:r>
+          </a:p>
+        </p:txBody>
+      </p:sp>
+      <p:sp>
+        <p:nvSpPr>
+          <p:cNvPr id="20" name="TextBox 19"/>
+          <p:cNvSpPr txBox="1"/>
+          <p:nvPr/>
+        </p:nvSpPr>
+        <p:spPr>
+          <a:xfrm>
+            <a:off x="3017520" y="4773168"/>
+            <a:ext cx="384048" cy="402336"/>
+          </a:xfrm>
+          <a:prstGeom prst="rect">
+            <a:avLst/>
+          </a:prstGeom>
+          <a:noFill/>
+        </p:spPr>
+        <p:txBody>
+          <a:bodyPr wrap="square" anchor="ctr" lIns="36576" rIns="36576" tIns="18288" bIns="18288">
+            <a:spAutoFit/>
+          </a:bodyPr>
+          <a:lstStyle/>
+          <a:p>
+            <a:pPr algn="ctr">
+              <a:lnSpc>
+                <a:spcPct val="105000"/>
+              </a:lnSpc>
+            </a:pPr>
+            <a:r>
+              <a:rPr sz="2000" b="1">
+                <a:solidFill>
+                  <a:srgbClr val="9FB6C0"/>
+                </a:solidFill>
+                <a:latin typeface="Microsoft YaHei"/>
+              </a:rPr>
+              <a:t>→</a:t>
+            </a:r>
+          </a:p>
+        </p:txBody>
+      </p:sp>
+      <p:sp>
+        <p:nvSpPr>
+          <p:cNvPr id="21" name="Rounded Rectangle 20"/>
+          <p:cNvSpPr/>
+          <p:nvPr/>
+        </p:nvSpPr>
+        <p:spPr>
+          <a:xfrm>
+            <a:off x="3383280" y="4562856"/>
+            <a:ext cx="2331720" cy="822960"/>
+          </a:xfrm>
+          <a:prstGeom prst="roundRect">
+            <a:avLst>
+              <a:gd name="adj" fmla="val 12000"/>
+            </a:avLst>
+          </a:prstGeom>
+          <a:solidFill>
+            <a:srgbClr val="F4FAFB"/>
+          </a:solidFill>
+          <a:ln w="12700">
+            <a:solidFill>
+              <a:srgbClr val="DCE8EE"/>
+            </a:solidFill>
+          </a:ln>
+          <a:effectLst/>
+        </p:spPr>
+        <p:style>
+          <a:lnRef idx="1">
+            <a:schemeClr val="accent1"/>
+          </a:lnRef>
+          <a:fillRef idx="3">
+            <a:schemeClr val="accent1"/>
+          </a:fillRef>
+          <a:effectRef idx="2">
+            <a:schemeClr val="accent1"/>
+          </a:effectRef>
+          <a:fontRef idx="minor">
+            <a:schemeClr val="lt1"/>
+          </a:fontRef>
+        </p:style>
+        <p:txBody>
+          <a:bodyPr rtlCol="0" anchor="ctr"/>
+          <a:lstStyle/>
+          <a:p>
+            <a:pPr algn="ctr"/>
+          </a:p>
+        </p:txBody>
+      </p:sp>
+      <p:sp>
+        <p:nvSpPr>
+          <p:cNvPr id="22" name="TextBox 21"/>
+          <p:cNvSpPr txBox="1"/>
+          <p:nvPr/>
+        </p:nvSpPr>
+        <p:spPr>
+          <a:xfrm>
+            <a:off x="3438144" y="4562856"/>
+            <a:ext cx="2221991" cy="822960"/>
+          </a:xfrm>
+          <a:prstGeom prst="rect">
+            <a:avLst/>
+          </a:prstGeom>
+          <a:noFill/>
+        </p:spPr>
+        <p:txBody>
+          <a:bodyPr wrap="square" anchor="ctr" lIns="36576" rIns="36576" tIns="18288" bIns="18288">
+            <a:spAutoFit/>
+          </a:bodyPr>
+          <a:lstStyle/>
+          <a:p>
+            <a:pPr algn="ctr">
+              <a:lnSpc>
+                <a:spcPct val="100000"/>
+              </a:lnSpc>
+            </a:pPr>
+            <a:r>
+              <a:rPr sz="1250" b="1">
+                <a:solidFill>
+                  <a:srgbClr val="17313F"/>
+                </a:solidFill>
+                <a:latin typeface="Microsoft YaHei"/>
+              </a:rPr>
+              <a:t>PPV 统计校准</a:t>
+            </a:r>
+          </a:p>
+        </p:txBody>
+      </p:sp>
+      <p:sp>
+        <p:nvSpPr>
+          <p:cNvPr id="23" name="TextBox 22"/>
+          <p:cNvSpPr txBox="1"/>
+          <p:nvPr/>
+        </p:nvSpPr>
+        <p:spPr>
+          <a:xfrm>
+            <a:off x="5715000" y="4773168"/>
+            <a:ext cx="384048" cy="402336"/>
+          </a:xfrm>
+          <a:prstGeom prst="rect">
+            <a:avLst/>
+          </a:prstGeom>
+          <a:noFill/>
+        </p:spPr>
+        <p:txBody>
+          <a:bodyPr wrap="square" anchor="ctr" lIns="36576" rIns="36576" tIns="18288" bIns="18288">
+            <a:spAutoFit/>
+          </a:bodyPr>
+          <a:lstStyle/>
+          <a:p>
+            <a:pPr algn="ctr">
+              <a:lnSpc>
+                <a:spcPct val="105000"/>
+              </a:lnSpc>
+            </a:pPr>
+            <a:r>
+              <a:rPr sz="2000" b="1">
+                <a:solidFill>
+                  <a:srgbClr val="9FB6C0"/>
+                </a:solidFill>
+                <a:latin typeface="Microsoft YaHei"/>
+              </a:rPr>
+              <a:t>→</a:t>
+            </a:r>
+          </a:p>
+        </p:txBody>
+      </p:sp>
+      <p:sp>
+        <p:nvSpPr>
+          <p:cNvPr id="24" name="Rounded Rectangle 23"/>
+          <p:cNvSpPr/>
+          <p:nvPr/>
+        </p:nvSpPr>
+        <p:spPr>
+          <a:xfrm>
+            <a:off x="6080760" y="4562856"/>
+            <a:ext cx="2331720" cy="822960"/>
+          </a:xfrm>
+          <a:prstGeom prst="roundRect">
+            <a:avLst>
+              <a:gd name="adj" fmla="val 12000"/>
+            </a:avLst>
+          </a:prstGeom>
+          <a:solidFill>
+            <a:srgbClr val="F4FAFB"/>
+          </a:solidFill>
+          <a:ln w="12700">
+            <a:solidFill>
+              <a:srgbClr val="DCE8EE"/>
+            </a:solidFill>
+          </a:ln>
+          <a:effectLst/>
+        </p:spPr>
+        <p:style>
+          <a:lnRef idx="1">
+            <a:schemeClr val="accent1"/>
+          </a:lnRef>
+          <a:fillRef idx="3">
+            <a:schemeClr val="accent1"/>
+          </a:fillRef>
+          <a:effectRef idx="2">
+            <a:schemeClr val="accent1"/>
+          </a:effectRef>
+          <a:fontRef idx="minor">
+            <a:schemeClr val="lt1"/>
+          </a:fontRef>
+        </p:style>
+        <p:txBody>
+          <a:bodyPr rtlCol="0" anchor="ctr"/>
+          <a:lstStyle/>
+          <a:p>
+            <a:pPr algn="ctr"/>
+          </a:p>
+        </p:txBody>
+      </p:sp>
+      <p:sp>
+        <p:nvSpPr>
+          <p:cNvPr id="25" name="TextBox 24"/>
+          <p:cNvSpPr txBox="1"/>
+          <p:nvPr/>
+        </p:nvSpPr>
+        <p:spPr>
+          <a:xfrm>
+            <a:off x="6135624" y="4562856"/>
+            <a:ext cx="2221991" cy="822960"/>
+          </a:xfrm>
+          <a:prstGeom prst="rect">
+            <a:avLst/>
+          </a:prstGeom>
+          <a:noFill/>
+        </p:spPr>
+        <p:txBody>
+          <a:bodyPr wrap="square" anchor="ctr" lIns="36576" rIns="36576" tIns="18288" bIns="18288">
+            <a:spAutoFit/>
+          </a:bodyPr>
+          <a:lstStyle/>
+          <a:p>
+            <a:pPr algn="ctr">
+              <a:lnSpc>
+                <a:spcPct val="100000"/>
+              </a:lnSpc>
+            </a:pPr>
+            <a:r>
+              <a:rPr sz="1250" b="1">
+                <a:solidFill>
+                  <a:srgbClr val="17313F"/>
+                </a:solidFill>
+                <a:latin typeface="Microsoft YaHei"/>
+              </a:rPr>
+              <a:t>人工审批</a:t>
+            </a:r>
+          </a:p>
+        </p:txBody>
+      </p:sp>
+      <p:sp>
+        <p:nvSpPr>
+          <p:cNvPr id="26" name="TextBox 25"/>
+          <p:cNvSpPr txBox="1"/>
+          <p:nvPr/>
+        </p:nvSpPr>
+        <p:spPr>
+          <a:xfrm>
+            <a:off x="8412480" y="4773168"/>
+            <a:ext cx="384048" cy="402336"/>
+          </a:xfrm>
+          <a:prstGeom prst="rect">
+            <a:avLst/>
+          </a:prstGeom>
+          <a:noFill/>
+        </p:spPr>
+        <p:txBody>
+          <a:bodyPr wrap="square" anchor="ctr" lIns="36576" rIns="36576" tIns="18288" bIns="18288">
+            <a:spAutoFit/>
+          </a:bodyPr>
+          <a:lstStyle/>
+          <a:p>
+            <a:pPr algn="ctr">
+              <a:lnSpc>
+                <a:spcPct val="105000"/>
+              </a:lnSpc>
+            </a:pPr>
+            <a:r>
+              <a:rPr sz="2000" b="1">
+                <a:solidFill>
+                  <a:srgbClr val="9FB6C0"/>
+                </a:solidFill>
+                <a:latin typeface="Microsoft YaHei"/>
+              </a:rPr>
+              <a:t>→</a:t>
+            </a:r>
+          </a:p>
+        </p:txBody>
+      </p:sp>
+      <p:sp>
+        <p:nvSpPr>
+          <p:cNvPr id="27" name="Rounded Rectangle 26"/>
+          <p:cNvSpPr/>
+          <p:nvPr/>
+        </p:nvSpPr>
+        <p:spPr>
+          <a:xfrm>
+            <a:off x="8778240" y="4562856"/>
+            <a:ext cx="2331720" cy="822960"/>
+          </a:xfrm>
+          <a:prstGeom prst="roundRect">
+            <a:avLst>
+              <a:gd name="adj" fmla="val 12000"/>
+            </a:avLst>
+          </a:prstGeom>
+          <a:solidFill>
+            <a:srgbClr val="F4FAFB"/>
+          </a:solidFill>
+          <a:ln w="12700">
+            <a:solidFill>
+              <a:srgbClr val="DCE8EE"/>
+            </a:solidFill>
+          </a:ln>
+          <a:effectLst/>
+        </p:spPr>
+        <p:style>
+          <a:lnRef idx="1">
+            <a:schemeClr val="accent1"/>
+          </a:lnRef>
+          <a:fillRef idx="3">
+            <a:schemeClr val="accent1"/>
+          </a:fillRef>
+          <a:effectRef idx="2">
+            <a:schemeClr val="accent1"/>
+          </a:effectRef>
+          <a:fontRef idx="minor">
+            <a:schemeClr val="lt1"/>
+          </a:fontRef>
+        </p:style>
+        <p:txBody>
+          <a:bodyPr rtlCol="0" anchor="ctr"/>
+          <a:lstStyle/>
+          <a:p>
+            <a:pPr algn="ctr"/>
+          </a:p>
+        </p:txBody>
+      </p:sp>
+      <p:sp>
+        <p:nvSpPr>
+          <p:cNvPr id="28" name="TextBox 27"/>
+          <p:cNvSpPr txBox="1"/>
+          <p:nvPr/>
+        </p:nvSpPr>
+        <p:spPr>
+          <a:xfrm>
+            <a:off x="8833104" y="4562856"/>
+            <a:ext cx="2221991" cy="822960"/>
+          </a:xfrm>
+          <a:prstGeom prst="rect">
+            <a:avLst/>
+          </a:prstGeom>
+          <a:noFill/>
+        </p:spPr>
+        <p:txBody>
+          <a:bodyPr wrap="square" anchor="ctr" lIns="36576" rIns="36576" tIns="18288" bIns="18288">
+            <a:spAutoFit/>
+          </a:bodyPr>
+          <a:lstStyle/>
+          <a:p>
+            <a:pPr algn="ctr">
+              <a:lnSpc>
+                <a:spcPct val="100000"/>
+              </a:lnSpc>
+            </a:pPr>
+            <a:r>
+              <a:rPr sz="1250" b="1">
+                <a:solidFill>
+                  <a:srgbClr val="17313F"/>
+                </a:solidFill>
+                <a:latin typeface="Microsoft YaHei"/>
+              </a:rPr>
+              <a:t>新 T1 / T2 规则</a:t>
+            </a:r>
+          </a:p>
+        </p:txBody>
+      </p:sp>
+      <p:sp>
+        <p:nvSpPr>
+          <p:cNvPr id="29" name="Rounded Rectangle 28"/>
+          <p:cNvSpPr/>
+          <p:nvPr/>
+        </p:nvSpPr>
+        <p:spPr>
+          <a:xfrm>
+            <a:off x="548640" y="5495544"/>
+            <a:ext cx="11091672" cy="566928"/>
+          </a:xfrm>
+          <a:prstGeom prst="roundRect">
+            <a:avLst>
+              <a:gd name="adj" fmla="val 18000"/>
+            </a:avLst>
+          </a:prstGeom>
+          <a:solidFill>
+            <a:srgbClr val="F4FAFB"/>
+          </a:solidFill>
+          <a:ln w="15240">
+            <a:solidFill>
+              <a:srgbClr val="C9861A"/>
+            </a:solidFill>
+            <a:prstDash val="dash"/>
+          </a:ln>
+          <a:effectLst/>
+        </p:spPr>
+        <p:style>
+          <a:lnRef idx="1">
+            <a:schemeClr val="accent1"/>
+          </a:lnRef>
+          <a:fillRef idx="3">
+            <a:schemeClr val="accent1"/>
+          </a:fillRef>
+          <a:effectRef idx="2">
+            <a:schemeClr val="accent1"/>
+          </a:effectRef>
+          <a:fontRef idx="minor">
+            <a:schemeClr val="lt1"/>
+          </a:fontRef>
+        </p:style>
+        <p:txBody>
+          <a:bodyPr rtlCol="0" anchor="ctr"/>
+          <a:lstStyle/>
+          <a:p>
+            <a:pPr algn="ctr"/>
+          </a:p>
+        </p:txBody>
+      </p:sp>
+      <p:sp>
+        <p:nvSpPr>
+          <p:cNvPr id="30" name="TextBox 29"/>
+          <p:cNvSpPr txBox="1"/>
+          <p:nvPr/>
+        </p:nvSpPr>
+        <p:spPr>
+          <a:xfrm>
+            <a:off x="868680" y="5495544"/>
+            <a:ext cx="10515600" cy="566928"/>
+          </a:xfrm>
+          <a:prstGeom prst="rect">
+            <a:avLst/>
+          </a:prstGeom>
+          <a:noFill/>
+        </p:spPr>
+        <p:txBody>
+          <a:bodyPr wrap="square" anchor="ctr" lIns="36576" rIns="36576" tIns="18288" bIns="18288">
+            <a:spAutoFit/>
+          </a:bodyPr>
+          <a:lstStyle/>
+          <a:p>
+            <a:pPr algn="l">
+              <a:lnSpc>
+                <a:spcPct val="105000"/>
+              </a:lnSpc>
+            </a:pPr>
+            <a:r>
+              <a:rPr sz="1250" b="1">
+                <a:solidFill>
+                  <a:srgbClr val="C9861A"/>
+                </a:solidFill>
+                <a:latin typeface="Microsoft YaHei"/>
+              </a:rPr>
+              <a:t>闸门：</a:t>
+            </a:r>
+            <a:r>
+              <a:rPr sz="1250" b="0">
+                <a:solidFill>
+                  <a:srgbClr val="17313F"/>
+                </a:solidFill>
+                <a:latin typeface="Microsoft YaHei"/>
+              </a:rPr>
+              <a:t>Agent 只提候选；达标 + 审批后才成为正式规则 —— 自我进化在闸门内。</a:t>
+            </a:r>
+          </a:p>
+        </p:txBody>
+      </p:sp>
+    </p:spTree>
+  </p:cSld>
+  <p:clrMapOvr>
+    <a:masterClrMapping/>
+  </p:clrMapOvr>
+</p:sld>
+</file>
+
 <file path=ppt/slides/slide2.xml><?xml version="1.0" encoding="utf-8"?>
+<p:sld xmlns:a="http://schemas.openxmlformats.org/drawingml/2006/main" xmlns:p="http://schemas.openxmlformats.org/presentationml/2006/main" xmlns:r="http://schemas.openxmlformats.org/officeDocument/2006/relationships">
+  <p:cSld>
+    <p:bg>
+      <p:bgPr>
+        <a:solidFill>
+          <a:srgbClr val="FFFFFF"/>
+        </a:solidFill>
+        <a:effectLst/>
+      </p:bgPr>
+    </p:bg>
+    <p:spTree>
+      <p:nvGrpSpPr>
+        <p:cNvPr id="1" name=""/>
+        <p:cNvGrpSpPr/>
+        <p:nvPr/>
+      </p:nvGrpSpPr>
+      <p:grpSpPr/>
+      <p:sp>
+        <p:nvSpPr>
+          <p:cNvPr id="2" name="Rectangle 1"/>
+          <p:cNvSpPr/>
+          <p:nvPr/>
+        </p:nvSpPr>
+        <p:spPr>
+          <a:xfrm>
+            <a:off x="0" y="0"/>
+            <a:ext cx="256032" cy="6858000"/>
+          </a:xfrm>
+          <a:prstGeom prst="rect">
+            <a:avLst/>
+          </a:prstGeom>
+          <a:solidFill>
+            <a:srgbClr val="1BA39C"/>
+          </a:solidFill>
+          <a:ln>
+            <a:noFill/>
+          </a:ln>
+          <a:effectLst/>
+        </p:spPr>
+        <p:style>
+          <a:lnRef idx="1">
+            <a:schemeClr val="accent1"/>
+          </a:lnRef>
+          <a:fillRef idx="3">
+            <a:schemeClr val="accent1"/>
+          </a:fillRef>
+          <a:effectRef idx="2">
+            <a:schemeClr val="accent1"/>
+          </a:effectRef>
+          <a:fontRef idx="minor">
+            <a:schemeClr val="lt1"/>
+          </a:fontRef>
+        </p:style>
+        <p:txBody>
+          <a:bodyPr rtlCol="0" anchor="ctr"/>
+          <a:lstStyle/>
+          <a:p>
+            <a:pPr algn="ctr"/>
+          </a:p>
+        </p:txBody>
+      </p:sp>
+      <p:sp>
+        <p:nvSpPr>
+          <p:cNvPr id="3" name="TextBox 2"/>
+          <p:cNvSpPr txBox="1"/>
+          <p:nvPr/>
+        </p:nvSpPr>
+        <p:spPr>
+          <a:xfrm>
+            <a:off x="548640" y="457200"/>
+            <a:ext cx="9144000" cy="274320"/>
+          </a:xfrm>
+          <a:prstGeom prst="rect">
+            <a:avLst/>
+          </a:prstGeom>
+          <a:noFill/>
+        </p:spPr>
+        <p:txBody>
+          <a:bodyPr wrap="square" anchor="t" lIns="36576" rIns="36576" tIns="18288" bIns="18288">
+            <a:spAutoFit/>
+          </a:bodyPr>
+          <a:lstStyle/>
+          <a:p>
+            <a:pPr algn="l">
+              <a:lnSpc>
+                <a:spcPct val="105000"/>
+              </a:lnSpc>
+            </a:pPr>
+            <a:r>
+              <a:rPr sz="1200" b="1">
+                <a:solidFill>
+                  <a:srgbClr val="1BA39C"/>
+                </a:solidFill>
+                <a:latin typeface="Microsoft YaHei"/>
+              </a:rPr>
+              <a:t>目标与收益</a:t>
+            </a:r>
+          </a:p>
+        </p:txBody>
+      </p:sp>
+      <p:sp>
+        <p:nvSpPr>
+          <p:cNvPr id="4" name="TextBox 3"/>
+          <p:cNvSpPr txBox="1"/>
+          <p:nvPr/>
+        </p:nvSpPr>
+        <p:spPr>
+          <a:xfrm>
+            <a:off x="548640" y="749808"/>
+            <a:ext cx="11064240" cy="822960"/>
+          </a:xfrm>
+          <a:prstGeom prst="rect">
+            <a:avLst/>
+          </a:prstGeom>
+          <a:noFill/>
+        </p:spPr>
+        <p:txBody>
+          <a:bodyPr wrap="square" anchor="t" lIns="36576" rIns="36576" tIns="18288" bIns="18288">
+            <a:spAutoFit/>
+          </a:bodyPr>
+          <a:lstStyle/>
+          <a:p>
+            <a:pPr algn="l">
+              <a:lnSpc>
+                <a:spcPct val="105000"/>
+              </a:lnSpc>
+            </a:pPr>
+            <a:r>
+              <a:rPr sz="3000" b="1">
+                <a:solidFill>
+                  <a:srgbClr val="17313F"/>
+                </a:solidFill>
+                <a:latin typeface="Microsoft YaHei"/>
+              </a:rPr>
+              <a:t>让法务前置发现潜在洗钱行为</a:t>
+            </a:r>
+          </a:p>
+        </p:txBody>
+      </p:sp>
+      <p:sp>
+        <p:nvSpPr>
+          <p:cNvPr id="5" name="TextBox 4"/>
+          <p:cNvSpPr txBox="1"/>
+          <p:nvPr/>
+        </p:nvSpPr>
+        <p:spPr>
+          <a:xfrm>
+            <a:off x="566928" y="1627632"/>
+            <a:ext cx="10972800" cy="548640"/>
+          </a:xfrm>
+          <a:prstGeom prst="rect">
+            <a:avLst/>
+          </a:prstGeom>
+          <a:noFill/>
+        </p:spPr>
+        <p:txBody>
+          <a:bodyPr wrap="square" anchor="t" lIns="36576" rIns="36576" tIns="18288" bIns="18288">
+            <a:spAutoFit/>
+          </a:bodyPr>
+          <a:lstStyle/>
+          <a:p>
+            <a:pPr algn="l">
+              <a:lnSpc>
+                <a:spcPct val="115000"/>
+              </a:lnSpc>
+            </a:pPr>
+            <a:r>
+              <a:rPr sz="1400" b="0">
+                <a:solidFill>
+                  <a:srgbClr val="71838F"/>
+                </a:solidFill>
+                <a:latin typeface="Microsoft YaHei"/>
+              </a:rPr>
+              <a:t>从「事后追查」转向「事前识别」—— 在付款出账前把风险拦下来。</a:t>
+            </a:r>
+          </a:p>
+        </p:txBody>
+      </p:sp>
+      <p:sp>
+        <p:nvSpPr>
+          <p:cNvPr id="6" name="Rounded Rectangle 5"/>
+          <p:cNvSpPr/>
+          <p:nvPr/>
+        </p:nvSpPr>
+        <p:spPr>
+          <a:xfrm>
+            <a:off x="548640" y="2377440"/>
+            <a:ext cx="5358384" cy="1783080"/>
+          </a:xfrm>
+          <a:prstGeom prst="roundRect">
+            <a:avLst>
+              <a:gd name="adj" fmla="val 10000"/>
+            </a:avLst>
+          </a:prstGeom>
+          <a:solidFill>
+            <a:srgbClr val="F4FAFB"/>
+          </a:solidFill>
+          <a:ln w="12700">
+            <a:solidFill>
+              <a:srgbClr val="DCE8EE"/>
+            </a:solidFill>
+          </a:ln>
+          <a:effectLst/>
+        </p:spPr>
+        <p:style>
+          <a:lnRef idx="1">
+            <a:schemeClr val="accent1"/>
+          </a:lnRef>
+          <a:fillRef idx="3">
+            <a:schemeClr val="accent1"/>
+          </a:fillRef>
+          <a:effectRef idx="2">
+            <a:schemeClr val="accent1"/>
+          </a:effectRef>
+          <a:fontRef idx="minor">
+            <a:schemeClr val="lt1"/>
+          </a:fontRef>
+        </p:style>
+        <p:txBody>
+          <a:bodyPr rtlCol="0" anchor="ctr"/>
+          <a:lstStyle/>
+          <a:p>
+            <a:pPr algn="ctr"/>
+          </a:p>
+        </p:txBody>
+      </p:sp>
+      <p:sp>
+        <p:nvSpPr>
+          <p:cNvPr id="7" name="Rounded Rectangle 6"/>
+          <p:cNvSpPr/>
+          <p:nvPr/>
+        </p:nvSpPr>
+        <p:spPr>
+          <a:xfrm>
+            <a:off x="822959" y="2670048"/>
+            <a:ext cx="566928" cy="566928"/>
+          </a:xfrm>
+          <a:prstGeom prst="roundRect">
+            <a:avLst>
+              <a:gd name="adj" fmla="val 25000"/>
+            </a:avLst>
+          </a:prstGeom>
+          <a:solidFill>
+            <a:srgbClr val="1BA39C"/>
+          </a:solidFill>
+          <a:ln>
+            <a:noFill/>
+          </a:ln>
+          <a:effectLst/>
+        </p:spPr>
+        <p:style>
+          <a:lnRef idx="1">
+            <a:schemeClr val="accent1"/>
+          </a:lnRef>
+          <a:fillRef idx="3">
+            <a:schemeClr val="accent1"/>
+          </a:fillRef>
+          <a:effectRef idx="2">
+            <a:schemeClr val="accent1"/>
+          </a:effectRef>
+          <a:fontRef idx="minor">
+            <a:schemeClr val="lt1"/>
+          </a:fontRef>
+        </p:style>
+        <p:txBody>
+          <a:bodyPr rtlCol="0" anchor="ctr" wrap="none"/>
+          <a:lstStyle/>
+          <a:p>
+            <a:pPr algn="ctr"/>
+            <a:r>
+              <a:rPr sz="2000" b="1">
+                <a:solidFill>
+                  <a:srgbClr val="FFFFFF"/>
+                </a:solidFill>
+                <a:latin typeface="Microsoft YaHei"/>
+              </a:rPr>
+              <a:t>1</a:t>
+            </a:r>
+          </a:p>
+        </p:txBody>
+      </p:sp>
+      <p:sp>
+        <p:nvSpPr>
+          <p:cNvPr id="8" name="TextBox 7"/>
+          <p:cNvSpPr txBox="1"/>
+          <p:nvPr/>
+        </p:nvSpPr>
+        <p:spPr>
+          <a:xfrm>
+            <a:off x="1572768" y="2651760"/>
+            <a:ext cx="4078224" cy="457200"/>
+          </a:xfrm>
+          <a:prstGeom prst="rect">
+            <a:avLst/>
+          </a:prstGeom>
+          <a:noFill/>
+        </p:spPr>
+        <p:txBody>
+          <a:bodyPr wrap="square" anchor="ctr" lIns="36576" rIns="36576" tIns="18288" bIns="18288">
+            <a:spAutoFit/>
+          </a:bodyPr>
+          <a:lstStyle/>
+          <a:p>
+            <a:pPr algn="l">
+              <a:lnSpc>
+                <a:spcPct val="105000"/>
+              </a:lnSpc>
+            </a:pPr>
+            <a:r>
+              <a:rPr sz="1650" b="1">
+                <a:solidFill>
+                  <a:srgbClr val="17313F"/>
+                </a:solidFill>
+                <a:latin typeface="Microsoft YaHei"/>
+              </a:rPr>
+              <a:t>前置识别</a:t>
+            </a:r>
+          </a:p>
+        </p:txBody>
+      </p:sp>
+      <p:sp>
+        <p:nvSpPr>
+          <p:cNvPr id="9" name="TextBox 8"/>
+          <p:cNvSpPr txBox="1"/>
+          <p:nvPr/>
+        </p:nvSpPr>
+        <p:spPr>
+          <a:xfrm>
+            <a:off x="859536" y="3310128"/>
+            <a:ext cx="4764024" cy="731520"/>
+          </a:xfrm>
+          <a:prstGeom prst="rect">
+            <a:avLst/>
+          </a:prstGeom>
+          <a:noFill/>
+        </p:spPr>
+        <p:txBody>
+          <a:bodyPr wrap="square" anchor="t" lIns="36576" rIns="36576" tIns="18288" bIns="18288">
+            <a:spAutoFit/>
+          </a:bodyPr>
+          <a:lstStyle/>
+          <a:p>
+            <a:pPr algn="l">
+              <a:lnSpc>
+                <a:spcPct val="118000"/>
+              </a:lnSpc>
+            </a:pPr>
+            <a:r>
+              <a:rPr sz="1250" b="0">
+                <a:solidFill>
+                  <a:srgbClr val="71838F"/>
+                </a:solidFill>
+                <a:latin typeface="Microsoft YaHei"/>
+              </a:rPr>
+              <a:t>付款进行中即识别潜在洗钱，把风险拦在出款前，而非事后审计。</a:t>
+            </a:r>
+          </a:p>
+        </p:txBody>
+      </p:sp>
+      <p:sp>
+        <p:nvSpPr>
+          <p:cNvPr id="10" name="Rounded Rectangle 9"/>
+          <p:cNvSpPr/>
+          <p:nvPr/>
+        </p:nvSpPr>
+        <p:spPr>
+          <a:xfrm>
+            <a:off x="6291072" y="2377440"/>
+            <a:ext cx="5358384" cy="1783080"/>
+          </a:xfrm>
+          <a:prstGeom prst="roundRect">
+            <a:avLst>
+              <a:gd name="adj" fmla="val 10000"/>
+            </a:avLst>
+          </a:prstGeom>
+          <a:solidFill>
+            <a:srgbClr val="F4FAFB"/>
+          </a:solidFill>
+          <a:ln w="12700">
+            <a:solidFill>
+              <a:srgbClr val="DCE8EE"/>
+            </a:solidFill>
+          </a:ln>
+          <a:effectLst/>
+        </p:spPr>
+        <p:style>
+          <a:lnRef idx="1">
+            <a:schemeClr val="accent1"/>
+          </a:lnRef>
+          <a:fillRef idx="3">
+            <a:schemeClr val="accent1"/>
+          </a:fillRef>
+          <a:effectRef idx="2">
+            <a:schemeClr val="accent1"/>
+          </a:effectRef>
+          <a:fontRef idx="minor">
+            <a:schemeClr val="lt1"/>
+          </a:fontRef>
+        </p:style>
+        <p:txBody>
+          <a:bodyPr rtlCol="0" anchor="ctr"/>
+          <a:lstStyle/>
+          <a:p>
+            <a:pPr algn="ctr"/>
+          </a:p>
+        </p:txBody>
+      </p:sp>
+      <p:sp>
+        <p:nvSpPr>
+          <p:cNvPr id="11" name="Rounded Rectangle 10"/>
+          <p:cNvSpPr/>
+          <p:nvPr/>
+        </p:nvSpPr>
+        <p:spPr>
+          <a:xfrm>
+            <a:off x="6565392" y="2670048"/>
+            <a:ext cx="566928" cy="566928"/>
+          </a:xfrm>
+          <a:prstGeom prst="roundRect">
+            <a:avLst>
+              <a:gd name="adj" fmla="val 25000"/>
+            </a:avLst>
+          </a:prstGeom>
+          <a:solidFill>
+            <a:srgbClr val="1BA39C"/>
+          </a:solidFill>
+          <a:ln>
+            <a:noFill/>
+          </a:ln>
+          <a:effectLst/>
+        </p:spPr>
+        <p:style>
+          <a:lnRef idx="1">
+            <a:schemeClr val="accent1"/>
+          </a:lnRef>
+          <a:fillRef idx="3">
+            <a:schemeClr val="accent1"/>
+          </a:fillRef>
+          <a:effectRef idx="2">
+            <a:schemeClr val="accent1"/>
+          </a:effectRef>
+          <a:fontRef idx="minor">
+            <a:schemeClr val="lt1"/>
+          </a:fontRef>
+        </p:style>
+        <p:txBody>
+          <a:bodyPr rtlCol="0" anchor="ctr" wrap="none"/>
+          <a:lstStyle/>
+          <a:p>
+            <a:pPr algn="ctr"/>
+            <a:r>
+              <a:rPr sz="2000" b="1">
+                <a:solidFill>
+                  <a:srgbClr val="FFFFFF"/>
+                </a:solidFill>
+                <a:latin typeface="Microsoft YaHei"/>
+              </a:rPr>
+              <a:t>2</a:t>
+            </a:r>
+          </a:p>
+        </p:txBody>
+      </p:sp>
+      <p:sp>
+        <p:nvSpPr>
+          <p:cNvPr id="12" name="TextBox 11"/>
+          <p:cNvSpPr txBox="1"/>
+          <p:nvPr/>
+        </p:nvSpPr>
+        <p:spPr>
+          <a:xfrm>
+            <a:off x="7315200" y="2651760"/>
+            <a:ext cx="4078224" cy="457200"/>
+          </a:xfrm>
+          <a:prstGeom prst="rect">
+            <a:avLst/>
+          </a:prstGeom>
+          <a:noFill/>
+        </p:spPr>
+        <p:txBody>
+          <a:bodyPr wrap="square" anchor="ctr" lIns="36576" rIns="36576" tIns="18288" bIns="18288">
+            <a:spAutoFit/>
+          </a:bodyPr>
+          <a:lstStyle/>
+          <a:p>
+            <a:pPr algn="l">
+              <a:lnSpc>
+                <a:spcPct val="105000"/>
+              </a:lnSpc>
+            </a:pPr>
+            <a:r>
+              <a:rPr sz="1650" b="1">
+                <a:solidFill>
+                  <a:srgbClr val="17313F"/>
+                </a:solidFill>
+                <a:latin typeface="Microsoft YaHei"/>
+              </a:rPr>
+              <a:t>聚焦高价值</a:t>
+            </a:r>
+          </a:p>
+        </p:txBody>
+      </p:sp>
+      <p:sp>
+        <p:nvSpPr>
+          <p:cNvPr id="13" name="TextBox 12"/>
+          <p:cNvSpPr txBox="1"/>
+          <p:nvPr/>
+        </p:nvSpPr>
+        <p:spPr>
+          <a:xfrm>
+            <a:off x="6601968" y="3310128"/>
+            <a:ext cx="4764024" cy="731520"/>
+          </a:xfrm>
+          <a:prstGeom prst="rect">
+            <a:avLst/>
+          </a:prstGeom>
+          <a:noFill/>
+        </p:spPr>
+        <p:txBody>
+          <a:bodyPr wrap="square" anchor="t" lIns="36576" rIns="36576" tIns="18288" bIns="18288">
+            <a:spAutoFit/>
+          </a:bodyPr>
+          <a:lstStyle/>
+          <a:p>
+            <a:pPr algn="l">
+              <a:lnSpc>
+                <a:spcPct val="118000"/>
+              </a:lnSpc>
+            </a:pPr>
+            <a:r>
+              <a:rPr sz="1250" b="0">
+                <a:solidFill>
+                  <a:srgbClr val="71838F"/>
+                </a:solidFill>
+                <a:latin typeface="Microsoft YaHei"/>
+              </a:rPr>
+              <a:t>海量付款里把最该看的顶到前面，法务有限产能用在刀刃上。</a:t>
+            </a:r>
+          </a:p>
+        </p:txBody>
+      </p:sp>
+      <p:sp>
+        <p:nvSpPr>
+          <p:cNvPr id="14" name="Rounded Rectangle 13"/>
+          <p:cNvSpPr/>
+          <p:nvPr/>
+        </p:nvSpPr>
+        <p:spPr>
+          <a:xfrm>
+            <a:off x="548640" y="4297680"/>
+            <a:ext cx="5358384" cy="1783080"/>
+          </a:xfrm>
+          <a:prstGeom prst="roundRect">
+            <a:avLst>
+              <a:gd name="adj" fmla="val 10000"/>
+            </a:avLst>
+          </a:prstGeom>
+          <a:solidFill>
+            <a:srgbClr val="F4FAFB"/>
+          </a:solidFill>
+          <a:ln w="12700">
+            <a:solidFill>
+              <a:srgbClr val="DCE8EE"/>
+            </a:solidFill>
+          </a:ln>
+          <a:effectLst/>
+        </p:spPr>
+        <p:style>
+          <a:lnRef idx="1">
+            <a:schemeClr val="accent1"/>
+          </a:lnRef>
+          <a:fillRef idx="3">
+            <a:schemeClr val="accent1"/>
+          </a:fillRef>
+          <a:effectRef idx="2">
+            <a:schemeClr val="accent1"/>
+          </a:effectRef>
+          <a:fontRef idx="minor">
+            <a:schemeClr val="lt1"/>
+          </a:fontRef>
+        </p:style>
+        <p:txBody>
+          <a:bodyPr rtlCol="0" anchor="ctr"/>
+          <a:lstStyle/>
+          <a:p>
+            <a:pPr algn="ctr"/>
+          </a:p>
+        </p:txBody>
+      </p:sp>
+      <p:sp>
+        <p:nvSpPr>
+          <p:cNvPr id="15" name="Rounded Rectangle 14"/>
+          <p:cNvSpPr/>
+          <p:nvPr/>
+        </p:nvSpPr>
+        <p:spPr>
+          <a:xfrm>
+            <a:off x="822959" y="4590288"/>
+            <a:ext cx="566928" cy="566928"/>
+          </a:xfrm>
+          <a:prstGeom prst="roundRect">
+            <a:avLst>
+              <a:gd name="adj" fmla="val 25000"/>
+            </a:avLst>
+          </a:prstGeom>
+          <a:solidFill>
+            <a:srgbClr val="1BA39C"/>
+          </a:solidFill>
+          <a:ln>
+            <a:noFill/>
+          </a:ln>
+          <a:effectLst/>
+        </p:spPr>
+        <p:style>
+          <a:lnRef idx="1">
+            <a:schemeClr val="accent1"/>
+          </a:lnRef>
+          <a:fillRef idx="3">
+            <a:schemeClr val="accent1"/>
+          </a:fillRef>
+          <a:effectRef idx="2">
+            <a:schemeClr val="accent1"/>
+          </a:effectRef>
+          <a:fontRef idx="minor">
+            <a:schemeClr val="lt1"/>
+          </a:fontRef>
+        </p:style>
+        <p:txBody>
+          <a:bodyPr rtlCol="0" anchor="ctr" wrap="none"/>
+          <a:lstStyle/>
+          <a:p>
+            <a:pPr algn="ctr"/>
+            <a:r>
+              <a:rPr sz="2000" b="1">
+                <a:solidFill>
+                  <a:srgbClr val="FFFFFF"/>
+                </a:solidFill>
+                <a:latin typeface="Microsoft YaHei"/>
+              </a:rPr>
+              <a:t>3</a:t>
+            </a:r>
+          </a:p>
+        </p:txBody>
+      </p:sp>
+      <p:sp>
+        <p:nvSpPr>
+          <p:cNvPr id="16" name="TextBox 15"/>
+          <p:cNvSpPr txBox="1"/>
+          <p:nvPr/>
+        </p:nvSpPr>
+        <p:spPr>
+          <a:xfrm>
+            <a:off x="1572768" y="4572000"/>
+            <a:ext cx="4078224" cy="457200"/>
+          </a:xfrm>
+          <a:prstGeom prst="rect">
+            <a:avLst/>
+          </a:prstGeom>
+          <a:noFill/>
+        </p:spPr>
+        <p:txBody>
+          <a:bodyPr wrap="square" anchor="ctr" lIns="36576" rIns="36576" tIns="18288" bIns="18288">
+            <a:spAutoFit/>
+          </a:bodyPr>
+          <a:lstStyle/>
+          <a:p>
+            <a:pPr algn="l">
+              <a:lnSpc>
+                <a:spcPct val="105000"/>
+              </a:lnSpc>
+            </a:pPr>
+            <a:r>
+              <a:rPr sz="1650" b="1">
+                <a:solidFill>
+                  <a:srgbClr val="17313F"/>
+                </a:solidFill>
+                <a:latin typeface="Microsoft YaHei"/>
+              </a:rPr>
+              <a:t>可解释 · 可审计</a:t>
+            </a:r>
+          </a:p>
+        </p:txBody>
+      </p:sp>
+      <p:sp>
+        <p:nvSpPr>
+          <p:cNvPr id="17" name="TextBox 16"/>
+          <p:cNvSpPr txBox="1"/>
+          <p:nvPr/>
+        </p:nvSpPr>
+        <p:spPr>
+          <a:xfrm>
+            <a:off x="859536" y="5230368"/>
+            <a:ext cx="4764024" cy="731520"/>
+          </a:xfrm>
+          <a:prstGeom prst="rect">
+            <a:avLst/>
+          </a:prstGeom>
+          <a:noFill/>
+        </p:spPr>
+        <p:txBody>
+          <a:bodyPr wrap="square" anchor="t" lIns="36576" rIns="36576" tIns="18288" bIns="18288">
+            <a:spAutoFit/>
+          </a:bodyPr>
+          <a:lstStyle/>
+          <a:p>
+            <a:pPr algn="l">
+              <a:lnSpc>
+                <a:spcPct val="118000"/>
+              </a:lnSpc>
+            </a:pPr>
+            <a:r>
+              <a:rPr sz="1250" b="0">
+                <a:solidFill>
+                  <a:srgbClr val="71838F"/>
+                </a:solidFill>
+                <a:latin typeface="Microsoft YaHei"/>
+              </a:rPr>
+              <a:t>每个告警都说得清「为什么」，分级与变更全程留痕，经得起监管追问。</a:t>
+            </a:r>
+          </a:p>
+        </p:txBody>
+      </p:sp>
+      <p:sp>
+        <p:nvSpPr>
+          <p:cNvPr id="18" name="Rounded Rectangle 17"/>
+          <p:cNvSpPr/>
+          <p:nvPr/>
+        </p:nvSpPr>
+        <p:spPr>
+          <a:xfrm>
+            <a:off x="6291072" y="4297680"/>
+            <a:ext cx="5358384" cy="1783080"/>
+          </a:xfrm>
+          <a:prstGeom prst="roundRect">
+            <a:avLst>
+              <a:gd name="adj" fmla="val 10000"/>
+            </a:avLst>
+          </a:prstGeom>
+          <a:solidFill>
+            <a:srgbClr val="F4FAFB"/>
+          </a:solidFill>
+          <a:ln w="12700">
+            <a:solidFill>
+              <a:srgbClr val="DCE8EE"/>
+            </a:solidFill>
+          </a:ln>
+          <a:effectLst/>
+        </p:spPr>
+        <p:style>
+          <a:lnRef idx="1">
+            <a:schemeClr val="accent1"/>
+          </a:lnRef>
+          <a:fillRef idx="3">
+            <a:schemeClr val="accent1"/>
+          </a:fillRef>
+          <a:effectRef idx="2">
+            <a:schemeClr val="accent1"/>
+          </a:effectRef>
+          <a:fontRef idx="minor">
+            <a:schemeClr val="lt1"/>
+          </a:fontRef>
+        </p:style>
+        <p:txBody>
+          <a:bodyPr rtlCol="0" anchor="ctr"/>
+          <a:lstStyle/>
+          <a:p>
+            <a:pPr algn="ctr"/>
+          </a:p>
+        </p:txBody>
+      </p:sp>
+      <p:sp>
+        <p:nvSpPr>
+          <p:cNvPr id="19" name="Rounded Rectangle 18"/>
+          <p:cNvSpPr/>
+          <p:nvPr/>
+        </p:nvSpPr>
+        <p:spPr>
+          <a:xfrm>
+            <a:off x="6565392" y="4590288"/>
+            <a:ext cx="566928" cy="566928"/>
+          </a:xfrm>
+          <a:prstGeom prst="roundRect">
+            <a:avLst>
+              <a:gd name="adj" fmla="val 25000"/>
+            </a:avLst>
+          </a:prstGeom>
+          <a:solidFill>
+            <a:srgbClr val="1BA39C"/>
+          </a:solidFill>
+          <a:ln>
+            <a:noFill/>
+          </a:ln>
+          <a:effectLst/>
+        </p:spPr>
+        <p:style>
+          <a:lnRef idx="1">
+            <a:schemeClr val="accent1"/>
+          </a:lnRef>
+          <a:fillRef idx="3">
+            <a:schemeClr val="accent1"/>
+          </a:fillRef>
+          <a:effectRef idx="2">
+            <a:schemeClr val="accent1"/>
+          </a:effectRef>
+          <a:fontRef idx="minor">
+            <a:schemeClr val="lt1"/>
+          </a:fontRef>
+        </p:style>
+        <p:txBody>
+          <a:bodyPr rtlCol="0" anchor="ctr" wrap="none"/>
+          <a:lstStyle/>
+          <a:p>
+            <a:pPr algn="ctr"/>
+            <a:r>
+              <a:rPr sz="2000" b="1">
+                <a:solidFill>
+                  <a:srgbClr val="FFFFFF"/>
+                </a:solidFill>
+                <a:latin typeface="Microsoft YaHei"/>
+              </a:rPr>
+              <a:t>4</a:t>
+            </a:r>
+          </a:p>
+        </p:txBody>
+      </p:sp>
+      <p:sp>
+        <p:nvSpPr>
+          <p:cNvPr id="20" name="TextBox 19"/>
+          <p:cNvSpPr txBox="1"/>
+          <p:nvPr/>
+        </p:nvSpPr>
+        <p:spPr>
+          <a:xfrm>
+            <a:off x="7315200" y="4572000"/>
+            <a:ext cx="4078224" cy="457200"/>
+          </a:xfrm>
+          <a:prstGeom prst="rect">
+            <a:avLst/>
+          </a:prstGeom>
+          <a:noFill/>
+        </p:spPr>
+        <p:txBody>
+          <a:bodyPr wrap="square" anchor="ctr" lIns="36576" rIns="36576" tIns="18288" bIns="18288">
+            <a:spAutoFit/>
+          </a:bodyPr>
+          <a:lstStyle/>
+          <a:p>
+            <a:pPr algn="l">
+              <a:lnSpc>
+                <a:spcPct val="105000"/>
+              </a:lnSpc>
+            </a:pPr>
+            <a:r>
+              <a:rPr sz="1650" b="1">
+                <a:solidFill>
+                  <a:srgbClr val="17313F"/>
+                </a:solidFill>
+                <a:latin typeface="Microsoft YaHei"/>
+              </a:rPr>
+              <a:t>越用越准 · 提效</a:t>
+            </a:r>
+          </a:p>
+        </p:txBody>
+      </p:sp>
+      <p:sp>
+        <p:nvSpPr>
+          <p:cNvPr id="21" name="TextBox 20"/>
+          <p:cNvSpPr txBox="1"/>
+          <p:nvPr/>
+        </p:nvSpPr>
+        <p:spPr>
+          <a:xfrm>
+            <a:off x="6601968" y="5230368"/>
+            <a:ext cx="4764024" cy="731520"/>
+          </a:xfrm>
+          <a:prstGeom prst="rect">
+            <a:avLst/>
+          </a:prstGeom>
+          <a:noFill/>
+        </p:spPr>
+        <p:txBody>
+          <a:bodyPr wrap="square" anchor="t" lIns="36576" rIns="36576" tIns="18288" bIns="18288">
+            <a:spAutoFit/>
+          </a:bodyPr>
+          <a:lstStyle/>
+          <a:p>
+            <a:pPr algn="l">
+              <a:lnSpc>
+                <a:spcPct val="118000"/>
+              </a:lnSpc>
+            </a:pPr>
+            <a:r>
+              <a:rPr sz="1250" b="0">
+                <a:solidFill>
+                  <a:srgbClr val="71838F"/>
+                </a:solidFill>
+                <a:latin typeface="Microsoft YaHei"/>
+              </a:rPr>
+              <a:t>AI 调查取证提效；每次复核反哺系统，识别能力持续提升。</a:t>
+            </a:r>
+          </a:p>
+        </p:txBody>
+      </p:sp>
+    </p:spTree>
+  </p:cSld>
+  <p:clrMapOvr>
+    <a:masterClrMapping/>
+  </p:clrMapOvr>
+</p:sld>
+</file>
+
+<file path=ppt/slides/slide3.xml><?xml version="1.0" encoding="utf-8"?>
 <p:sld xmlns:a="http://schemas.openxmlformats.org/drawingml/2006/main" xmlns:r="http://schemas.openxmlformats.org/officeDocument/2006/relationships" xmlns:p="http://schemas.openxmlformats.org/presentationml/2006/main">
   <p:cSld name="Slide 2">
     <p:bg>
@@ -2349,7 +4524,7 @@
 </p:sld>
 </file>
 
-<file path=ppt/slides/slide3.xml><?xml version="1.0" encoding="utf-8"?>
+<file path=ppt/slides/slide4.xml><?xml version="1.0" encoding="utf-8"?>
 <p:sld xmlns:a="http://schemas.openxmlformats.org/drawingml/2006/main" xmlns:r="http://schemas.openxmlformats.org/officeDocument/2006/relationships" xmlns:p="http://schemas.openxmlformats.org/presentationml/2006/main">
   <p:cSld name="Slide 3">
     <p:bg>
@@ -3259,7 +5434,7 @@
 </p:sld>
 </file>
 
-<file path=ppt/slides/slide4.xml><?xml version="1.0" encoding="utf-8"?>
+<file path=ppt/slides/slide5.xml><?xml version="1.0" encoding="utf-8"?>
 <p:sld xmlns:a="http://schemas.openxmlformats.org/drawingml/2006/main" xmlns:r="http://schemas.openxmlformats.org/officeDocument/2006/relationships" xmlns:p="http://schemas.openxmlformats.org/presentationml/2006/main">
   <p:cSld name="Slide 4">
     <p:bg>
@@ -4557,7 +6732,7 @@
 </p:sld>
 </file>
 
-<file path=ppt/slides/slide5.xml><?xml version="1.0" encoding="utf-8"?>
+<file path=ppt/slides/slide6.xml><?xml version="1.0" encoding="utf-8"?>
 <p:sld xmlns:a="http://schemas.openxmlformats.org/drawingml/2006/main" xmlns:r="http://schemas.openxmlformats.org/officeDocument/2006/relationships" xmlns:p="http://schemas.openxmlformats.org/presentationml/2006/main">
   <p:cSld name="Slide 5">
     <p:bg>
@@ -5870,7 +8045,7 @@
 </p:sld>
 </file>
 
-<file path=ppt/slides/slide6.xml><?xml version="1.0" encoding="utf-8"?>
+<file path=ppt/slides/slide7.xml><?xml version="1.0" encoding="utf-8"?>
 <p:sld xmlns:a="http://schemas.openxmlformats.org/drawingml/2006/main" xmlns:r="http://schemas.openxmlformats.org/officeDocument/2006/relationships" xmlns:p="http://schemas.openxmlformats.org/presentationml/2006/main">
   <p:cSld name="Slide 6">
     <p:bg>
@@ -7599,7 +9774,7 @@
 </p:sld>
 </file>
 
-<file path=ppt/slides/slide7.xml><?xml version="1.0" encoding="utf-8"?>
+<file path=ppt/slides/slide8.xml><?xml version="1.0" encoding="utf-8"?>
 <p:sld xmlns:a="http://schemas.openxmlformats.org/drawingml/2006/main" xmlns:r="http://schemas.openxmlformats.org/officeDocument/2006/relationships" xmlns:p="http://schemas.openxmlformats.org/presentationml/2006/main">
   <p:cSld name="Slide 8">
     <p:bg>
@@ -8705,7 +10880,7 @@
 </p:sld>
 </file>
 
-<file path=ppt/slides/slide8.xml><?xml version="1.0" encoding="utf-8"?>
+<file path=ppt/slides/slide9.xml><?xml version="1.0" encoding="utf-8"?>
 <p:sld xmlns:a="http://schemas.openxmlformats.org/drawingml/2006/main" xmlns:r="http://schemas.openxmlformats.org/officeDocument/2006/relationships" xmlns:p="http://schemas.openxmlformats.org/presentationml/2006/main">
   <p:cSld name="Slide 9">
     <p:bg>
@@ -9290,917 +11465,6 @@
               <a:t>原型演示 · 公司付款数据为合成数据，外部数据源 / Hermes 框架 / 付款冻结为待对接项。</a:t>
             </a:r>
             <a:endParaRPr lang="en-US" sz="1000" dirty="0"/>
-          </a:p>
-        </p:txBody>
-      </p:sp>
-    </p:spTree>
-  </p:cSld>
-  <p:clrMapOvr>
-    <a:masterClrMapping/>
-  </p:clrMapOvr>
-</p:sld>
-</file>
-
-<file path=ppt/slides/slide9.xml><?xml version="1.0" encoding="utf-8"?>
-<p:sld xmlns:a="http://schemas.openxmlformats.org/drawingml/2006/main" xmlns:p="http://schemas.openxmlformats.org/presentationml/2006/main" xmlns:r="http://schemas.openxmlformats.org/officeDocument/2006/relationships">
-  <p:cSld>
-    <p:bg>
-      <p:bgPr>
-        <a:solidFill>
-          <a:srgbClr val="FFFFFF"/>
-        </a:solidFill>
-        <a:effectLst/>
-      </p:bgPr>
-    </p:bg>
-    <p:spTree>
-      <p:nvGrpSpPr>
-        <p:cNvPr id="1" name=""/>
-        <p:cNvGrpSpPr/>
-        <p:nvPr/>
-      </p:nvGrpSpPr>
-      <p:grpSpPr/>
-      <p:sp>
-        <p:nvSpPr>
-          <p:cNvPr id="2" name="Rectangle 1"/>
-          <p:cNvSpPr/>
-          <p:nvPr/>
-        </p:nvSpPr>
-        <p:spPr>
-          <a:xfrm>
-            <a:off x="0" y="0"/>
-            <a:ext cx="256032" cy="6858000"/>
-          </a:xfrm>
-          <a:prstGeom prst="rect">
-            <a:avLst/>
-          </a:prstGeom>
-          <a:solidFill>
-            <a:srgbClr val="1BA39C"/>
-          </a:solidFill>
-          <a:ln>
-            <a:noFill/>
-          </a:ln>
-          <a:effectLst/>
-        </p:spPr>
-        <p:style>
-          <a:lnRef idx="1">
-            <a:schemeClr val="accent1"/>
-          </a:lnRef>
-          <a:fillRef idx="3">
-            <a:schemeClr val="accent1"/>
-          </a:fillRef>
-          <a:effectRef idx="2">
-            <a:schemeClr val="accent1"/>
-          </a:effectRef>
-          <a:fontRef idx="minor">
-            <a:schemeClr val="lt1"/>
-          </a:fontRef>
-        </p:style>
-        <p:txBody>
-          <a:bodyPr rtlCol="0" anchor="ctr"/>
-          <a:lstStyle/>
-          <a:p>
-            <a:pPr algn="ctr"/>
-          </a:p>
-        </p:txBody>
-      </p:sp>
-      <p:sp>
-        <p:nvSpPr>
-          <p:cNvPr id="3" name="TextBox 2"/>
-          <p:cNvSpPr txBox="1"/>
-          <p:nvPr/>
-        </p:nvSpPr>
-        <p:spPr>
-          <a:xfrm>
-            <a:off x="548640" y="457200"/>
-            <a:ext cx="9144000" cy="274320"/>
-          </a:xfrm>
-          <a:prstGeom prst="rect">
-            <a:avLst/>
-          </a:prstGeom>
-          <a:noFill/>
-        </p:spPr>
-        <p:txBody>
-          <a:bodyPr wrap="square" anchor="t" lIns="36576" rIns="36576" tIns="18288" bIns="18288">
-            <a:spAutoFit/>
-          </a:bodyPr>
-          <a:lstStyle/>
-          <a:p>
-            <a:pPr algn="l">
-              <a:lnSpc>
-                <a:spcPct val="105000"/>
-              </a:lnSpc>
-            </a:pPr>
-            <a:r>
-              <a:rPr sz="1200" b="1">
-                <a:solidFill>
-                  <a:srgbClr val="1BA39C"/>
-                </a:solidFill>
-                <a:latin typeface="Microsoft YaHei"/>
-              </a:rPr>
-              <a:t>目标与收益</a:t>
-            </a:r>
-          </a:p>
-        </p:txBody>
-      </p:sp>
-      <p:sp>
-        <p:nvSpPr>
-          <p:cNvPr id="4" name="TextBox 3"/>
-          <p:cNvSpPr txBox="1"/>
-          <p:nvPr/>
-        </p:nvSpPr>
-        <p:spPr>
-          <a:xfrm>
-            <a:off x="548640" y="749808"/>
-            <a:ext cx="11064240" cy="822960"/>
-          </a:xfrm>
-          <a:prstGeom prst="rect">
-            <a:avLst/>
-          </a:prstGeom>
-          <a:noFill/>
-        </p:spPr>
-        <p:txBody>
-          <a:bodyPr wrap="square" anchor="t" lIns="36576" rIns="36576" tIns="18288" bIns="18288">
-            <a:spAutoFit/>
-          </a:bodyPr>
-          <a:lstStyle/>
-          <a:p>
-            <a:pPr algn="l">
-              <a:lnSpc>
-                <a:spcPct val="105000"/>
-              </a:lnSpc>
-            </a:pPr>
-            <a:r>
-              <a:rPr sz="3000" b="1">
-                <a:solidFill>
-                  <a:srgbClr val="17313F"/>
-                </a:solidFill>
-                <a:latin typeface="Microsoft YaHei"/>
-              </a:rPr>
-              <a:t>让法务前置发现潜在洗钱行为</a:t>
-            </a:r>
-          </a:p>
-        </p:txBody>
-      </p:sp>
-      <p:sp>
-        <p:nvSpPr>
-          <p:cNvPr id="5" name="TextBox 4"/>
-          <p:cNvSpPr txBox="1"/>
-          <p:nvPr/>
-        </p:nvSpPr>
-        <p:spPr>
-          <a:xfrm>
-            <a:off x="566928" y="1627632"/>
-            <a:ext cx="10972800" cy="548640"/>
-          </a:xfrm>
-          <a:prstGeom prst="rect">
-            <a:avLst/>
-          </a:prstGeom>
-          <a:noFill/>
-        </p:spPr>
-        <p:txBody>
-          <a:bodyPr wrap="square" anchor="t" lIns="36576" rIns="36576" tIns="18288" bIns="18288">
-            <a:spAutoFit/>
-          </a:bodyPr>
-          <a:lstStyle/>
-          <a:p>
-            <a:pPr algn="l">
-              <a:lnSpc>
-                <a:spcPct val="115000"/>
-              </a:lnSpc>
-            </a:pPr>
-            <a:r>
-              <a:rPr sz="1400" b="0">
-                <a:solidFill>
-                  <a:srgbClr val="71838F"/>
-                </a:solidFill>
-                <a:latin typeface="Microsoft YaHei"/>
-              </a:rPr>
-              <a:t>从「事后追查」转向「事前识别」—— 在付款出账前把风险拦下来。</a:t>
-            </a:r>
-          </a:p>
-        </p:txBody>
-      </p:sp>
-      <p:sp>
-        <p:nvSpPr>
-          <p:cNvPr id="6" name="Rounded Rectangle 5"/>
-          <p:cNvSpPr/>
-          <p:nvPr/>
-        </p:nvSpPr>
-        <p:spPr>
-          <a:xfrm>
-            <a:off x="548640" y="2377440"/>
-            <a:ext cx="5358384" cy="1783080"/>
-          </a:xfrm>
-          <a:prstGeom prst="roundRect">
-            <a:avLst>
-              <a:gd name="adj" fmla="val 10000"/>
-            </a:avLst>
-          </a:prstGeom>
-          <a:solidFill>
-            <a:srgbClr val="F4FAFB"/>
-          </a:solidFill>
-          <a:ln w="12700">
-            <a:solidFill>
-              <a:srgbClr val="DCE8EE"/>
-            </a:solidFill>
-          </a:ln>
-          <a:effectLst/>
-        </p:spPr>
-        <p:style>
-          <a:lnRef idx="1">
-            <a:schemeClr val="accent1"/>
-          </a:lnRef>
-          <a:fillRef idx="3">
-            <a:schemeClr val="accent1"/>
-          </a:fillRef>
-          <a:effectRef idx="2">
-            <a:schemeClr val="accent1"/>
-          </a:effectRef>
-          <a:fontRef idx="minor">
-            <a:schemeClr val="lt1"/>
-          </a:fontRef>
-        </p:style>
-        <p:txBody>
-          <a:bodyPr rtlCol="0" anchor="ctr"/>
-          <a:lstStyle/>
-          <a:p>
-            <a:pPr algn="ctr"/>
-          </a:p>
-        </p:txBody>
-      </p:sp>
-      <p:sp>
-        <p:nvSpPr>
-          <p:cNvPr id="7" name="Rounded Rectangle 6"/>
-          <p:cNvSpPr/>
-          <p:nvPr/>
-        </p:nvSpPr>
-        <p:spPr>
-          <a:xfrm>
-            <a:off x="822959" y="2670048"/>
-            <a:ext cx="566928" cy="566928"/>
-          </a:xfrm>
-          <a:prstGeom prst="roundRect">
-            <a:avLst>
-              <a:gd name="adj" fmla="val 25000"/>
-            </a:avLst>
-          </a:prstGeom>
-          <a:solidFill>
-            <a:srgbClr val="1BA39C"/>
-          </a:solidFill>
-          <a:ln>
-            <a:noFill/>
-          </a:ln>
-          <a:effectLst/>
-        </p:spPr>
-        <p:style>
-          <a:lnRef idx="1">
-            <a:schemeClr val="accent1"/>
-          </a:lnRef>
-          <a:fillRef idx="3">
-            <a:schemeClr val="accent1"/>
-          </a:fillRef>
-          <a:effectRef idx="2">
-            <a:schemeClr val="accent1"/>
-          </a:effectRef>
-          <a:fontRef idx="minor">
-            <a:schemeClr val="lt1"/>
-          </a:fontRef>
-        </p:style>
-        <p:txBody>
-          <a:bodyPr rtlCol="0" anchor="ctr" wrap="none"/>
-          <a:lstStyle/>
-          <a:p>
-            <a:pPr algn="ctr"/>
-            <a:r>
-              <a:rPr sz="2000" b="1">
-                <a:solidFill>
-                  <a:srgbClr val="FFFFFF"/>
-                </a:solidFill>
-                <a:latin typeface="Microsoft YaHei"/>
-              </a:rPr>
-              <a:t>1</a:t>
-            </a:r>
-          </a:p>
-        </p:txBody>
-      </p:sp>
-      <p:sp>
-        <p:nvSpPr>
-          <p:cNvPr id="8" name="TextBox 7"/>
-          <p:cNvSpPr txBox="1"/>
-          <p:nvPr/>
-        </p:nvSpPr>
-        <p:spPr>
-          <a:xfrm>
-            <a:off x="1572768" y="2651760"/>
-            <a:ext cx="4078224" cy="457200"/>
-          </a:xfrm>
-          <a:prstGeom prst="rect">
-            <a:avLst/>
-          </a:prstGeom>
-          <a:noFill/>
-        </p:spPr>
-        <p:txBody>
-          <a:bodyPr wrap="square" anchor="ctr" lIns="36576" rIns="36576" tIns="18288" bIns="18288">
-            <a:spAutoFit/>
-          </a:bodyPr>
-          <a:lstStyle/>
-          <a:p>
-            <a:pPr algn="l">
-              <a:lnSpc>
-                <a:spcPct val="105000"/>
-              </a:lnSpc>
-            </a:pPr>
-            <a:r>
-              <a:rPr sz="1650" b="1">
-                <a:solidFill>
-                  <a:srgbClr val="17313F"/>
-                </a:solidFill>
-                <a:latin typeface="Microsoft YaHei"/>
-              </a:rPr>
-              <a:t>前置识别</a:t>
-            </a:r>
-          </a:p>
-        </p:txBody>
-      </p:sp>
-      <p:sp>
-        <p:nvSpPr>
-          <p:cNvPr id="9" name="TextBox 8"/>
-          <p:cNvSpPr txBox="1"/>
-          <p:nvPr/>
-        </p:nvSpPr>
-        <p:spPr>
-          <a:xfrm>
-            <a:off x="859536" y="3310128"/>
-            <a:ext cx="4764024" cy="731520"/>
-          </a:xfrm>
-          <a:prstGeom prst="rect">
-            <a:avLst/>
-          </a:prstGeom>
-          <a:noFill/>
-        </p:spPr>
-        <p:txBody>
-          <a:bodyPr wrap="square" anchor="t" lIns="36576" rIns="36576" tIns="18288" bIns="18288">
-            <a:spAutoFit/>
-          </a:bodyPr>
-          <a:lstStyle/>
-          <a:p>
-            <a:pPr algn="l">
-              <a:lnSpc>
-                <a:spcPct val="118000"/>
-              </a:lnSpc>
-            </a:pPr>
-            <a:r>
-              <a:rPr sz="1250" b="0">
-                <a:solidFill>
-                  <a:srgbClr val="71838F"/>
-                </a:solidFill>
-                <a:latin typeface="Microsoft YaHei"/>
-              </a:rPr>
-              <a:t>付款进行中即识别潜在洗钱，把风险拦在出款前，而非事后审计。</a:t>
-            </a:r>
-          </a:p>
-        </p:txBody>
-      </p:sp>
-      <p:sp>
-        <p:nvSpPr>
-          <p:cNvPr id="10" name="Rounded Rectangle 9"/>
-          <p:cNvSpPr/>
-          <p:nvPr/>
-        </p:nvSpPr>
-        <p:spPr>
-          <a:xfrm>
-            <a:off x="6291072" y="2377440"/>
-            <a:ext cx="5358384" cy="1783080"/>
-          </a:xfrm>
-          <a:prstGeom prst="roundRect">
-            <a:avLst>
-              <a:gd name="adj" fmla="val 10000"/>
-            </a:avLst>
-          </a:prstGeom>
-          <a:solidFill>
-            <a:srgbClr val="F4FAFB"/>
-          </a:solidFill>
-          <a:ln w="12700">
-            <a:solidFill>
-              <a:srgbClr val="DCE8EE"/>
-            </a:solidFill>
-          </a:ln>
-          <a:effectLst/>
-        </p:spPr>
-        <p:style>
-          <a:lnRef idx="1">
-            <a:schemeClr val="accent1"/>
-          </a:lnRef>
-          <a:fillRef idx="3">
-            <a:schemeClr val="accent1"/>
-          </a:fillRef>
-          <a:effectRef idx="2">
-            <a:schemeClr val="accent1"/>
-          </a:effectRef>
-          <a:fontRef idx="minor">
-            <a:schemeClr val="lt1"/>
-          </a:fontRef>
-        </p:style>
-        <p:txBody>
-          <a:bodyPr rtlCol="0" anchor="ctr"/>
-          <a:lstStyle/>
-          <a:p>
-            <a:pPr algn="ctr"/>
-          </a:p>
-        </p:txBody>
-      </p:sp>
-      <p:sp>
-        <p:nvSpPr>
-          <p:cNvPr id="11" name="Rounded Rectangle 10"/>
-          <p:cNvSpPr/>
-          <p:nvPr/>
-        </p:nvSpPr>
-        <p:spPr>
-          <a:xfrm>
-            <a:off x="6565392" y="2670048"/>
-            <a:ext cx="566928" cy="566928"/>
-          </a:xfrm>
-          <a:prstGeom prst="roundRect">
-            <a:avLst>
-              <a:gd name="adj" fmla="val 25000"/>
-            </a:avLst>
-          </a:prstGeom>
-          <a:solidFill>
-            <a:srgbClr val="1BA39C"/>
-          </a:solidFill>
-          <a:ln>
-            <a:noFill/>
-          </a:ln>
-          <a:effectLst/>
-        </p:spPr>
-        <p:style>
-          <a:lnRef idx="1">
-            <a:schemeClr val="accent1"/>
-          </a:lnRef>
-          <a:fillRef idx="3">
-            <a:schemeClr val="accent1"/>
-          </a:fillRef>
-          <a:effectRef idx="2">
-            <a:schemeClr val="accent1"/>
-          </a:effectRef>
-          <a:fontRef idx="minor">
-            <a:schemeClr val="lt1"/>
-          </a:fontRef>
-        </p:style>
-        <p:txBody>
-          <a:bodyPr rtlCol="0" anchor="ctr" wrap="none"/>
-          <a:lstStyle/>
-          <a:p>
-            <a:pPr algn="ctr"/>
-            <a:r>
-              <a:rPr sz="2000" b="1">
-                <a:solidFill>
-                  <a:srgbClr val="FFFFFF"/>
-                </a:solidFill>
-                <a:latin typeface="Microsoft YaHei"/>
-              </a:rPr>
-              <a:t>2</a:t>
-            </a:r>
-          </a:p>
-        </p:txBody>
-      </p:sp>
-      <p:sp>
-        <p:nvSpPr>
-          <p:cNvPr id="12" name="TextBox 11"/>
-          <p:cNvSpPr txBox="1"/>
-          <p:nvPr/>
-        </p:nvSpPr>
-        <p:spPr>
-          <a:xfrm>
-            <a:off x="7315200" y="2651760"/>
-            <a:ext cx="4078224" cy="457200"/>
-          </a:xfrm>
-          <a:prstGeom prst="rect">
-            <a:avLst/>
-          </a:prstGeom>
-          <a:noFill/>
-        </p:spPr>
-        <p:txBody>
-          <a:bodyPr wrap="square" anchor="ctr" lIns="36576" rIns="36576" tIns="18288" bIns="18288">
-            <a:spAutoFit/>
-          </a:bodyPr>
-          <a:lstStyle/>
-          <a:p>
-            <a:pPr algn="l">
-              <a:lnSpc>
-                <a:spcPct val="105000"/>
-              </a:lnSpc>
-            </a:pPr>
-            <a:r>
-              <a:rPr sz="1650" b="1">
-                <a:solidFill>
-                  <a:srgbClr val="17313F"/>
-                </a:solidFill>
-                <a:latin typeface="Microsoft YaHei"/>
-              </a:rPr>
-              <a:t>聚焦高价值</a:t>
-            </a:r>
-          </a:p>
-        </p:txBody>
-      </p:sp>
-      <p:sp>
-        <p:nvSpPr>
-          <p:cNvPr id="13" name="TextBox 12"/>
-          <p:cNvSpPr txBox="1"/>
-          <p:nvPr/>
-        </p:nvSpPr>
-        <p:spPr>
-          <a:xfrm>
-            <a:off x="6601968" y="3310128"/>
-            <a:ext cx="4764024" cy="731520"/>
-          </a:xfrm>
-          <a:prstGeom prst="rect">
-            <a:avLst/>
-          </a:prstGeom>
-          <a:noFill/>
-        </p:spPr>
-        <p:txBody>
-          <a:bodyPr wrap="square" anchor="t" lIns="36576" rIns="36576" tIns="18288" bIns="18288">
-            <a:spAutoFit/>
-          </a:bodyPr>
-          <a:lstStyle/>
-          <a:p>
-            <a:pPr algn="l">
-              <a:lnSpc>
-                <a:spcPct val="118000"/>
-              </a:lnSpc>
-            </a:pPr>
-            <a:r>
-              <a:rPr sz="1250" b="0">
-                <a:solidFill>
-                  <a:srgbClr val="71838F"/>
-                </a:solidFill>
-                <a:latin typeface="Microsoft YaHei"/>
-              </a:rPr>
-              <a:t>海量付款里把最该看的顶到前面，法务有限产能用在刀刃上。</a:t>
-            </a:r>
-          </a:p>
-        </p:txBody>
-      </p:sp>
-      <p:sp>
-        <p:nvSpPr>
-          <p:cNvPr id="14" name="Rounded Rectangle 13"/>
-          <p:cNvSpPr/>
-          <p:nvPr/>
-        </p:nvSpPr>
-        <p:spPr>
-          <a:xfrm>
-            <a:off x="548640" y="4297680"/>
-            <a:ext cx="5358384" cy="1783080"/>
-          </a:xfrm>
-          <a:prstGeom prst="roundRect">
-            <a:avLst>
-              <a:gd name="adj" fmla="val 10000"/>
-            </a:avLst>
-          </a:prstGeom>
-          <a:solidFill>
-            <a:srgbClr val="F4FAFB"/>
-          </a:solidFill>
-          <a:ln w="12700">
-            <a:solidFill>
-              <a:srgbClr val="DCE8EE"/>
-            </a:solidFill>
-          </a:ln>
-          <a:effectLst/>
-        </p:spPr>
-        <p:style>
-          <a:lnRef idx="1">
-            <a:schemeClr val="accent1"/>
-          </a:lnRef>
-          <a:fillRef idx="3">
-            <a:schemeClr val="accent1"/>
-          </a:fillRef>
-          <a:effectRef idx="2">
-            <a:schemeClr val="accent1"/>
-          </a:effectRef>
-          <a:fontRef idx="minor">
-            <a:schemeClr val="lt1"/>
-          </a:fontRef>
-        </p:style>
-        <p:txBody>
-          <a:bodyPr rtlCol="0" anchor="ctr"/>
-          <a:lstStyle/>
-          <a:p>
-            <a:pPr algn="ctr"/>
-          </a:p>
-        </p:txBody>
-      </p:sp>
-      <p:sp>
-        <p:nvSpPr>
-          <p:cNvPr id="15" name="Rounded Rectangle 14"/>
-          <p:cNvSpPr/>
-          <p:nvPr/>
-        </p:nvSpPr>
-        <p:spPr>
-          <a:xfrm>
-            <a:off x="822959" y="4590288"/>
-            <a:ext cx="566928" cy="566928"/>
-          </a:xfrm>
-          <a:prstGeom prst="roundRect">
-            <a:avLst>
-              <a:gd name="adj" fmla="val 25000"/>
-            </a:avLst>
-          </a:prstGeom>
-          <a:solidFill>
-            <a:srgbClr val="1BA39C"/>
-          </a:solidFill>
-          <a:ln>
-            <a:noFill/>
-          </a:ln>
-          <a:effectLst/>
-        </p:spPr>
-        <p:style>
-          <a:lnRef idx="1">
-            <a:schemeClr val="accent1"/>
-          </a:lnRef>
-          <a:fillRef idx="3">
-            <a:schemeClr val="accent1"/>
-          </a:fillRef>
-          <a:effectRef idx="2">
-            <a:schemeClr val="accent1"/>
-          </a:effectRef>
-          <a:fontRef idx="minor">
-            <a:schemeClr val="lt1"/>
-          </a:fontRef>
-        </p:style>
-        <p:txBody>
-          <a:bodyPr rtlCol="0" anchor="ctr" wrap="none"/>
-          <a:lstStyle/>
-          <a:p>
-            <a:pPr algn="ctr"/>
-            <a:r>
-              <a:rPr sz="2000" b="1">
-                <a:solidFill>
-                  <a:srgbClr val="FFFFFF"/>
-                </a:solidFill>
-                <a:latin typeface="Microsoft YaHei"/>
-              </a:rPr>
-              <a:t>3</a:t>
-            </a:r>
-          </a:p>
-        </p:txBody>
-      </p:sp>
-      <p:sp>
-        <p:nvSpPr>
-          <p:cNvPr id="16" name="TextBox 15"/>
-          <p:cNvSpPr txBox="1"/>
-          <p:nvPr/>
-        </p:nvSpPr>
-        <p:spPr>
-          <a:xfrm>
-            <a:off x="1572768" y="4572000"/>
-            <a:ext cx="4078224" cy="457200"/>
-          </a:xfrm>
-          <a:prstGeom prst="rect">
-            <a:avLst/>
-          </a:prstGeom>
-          <a:noFill/>
-        </p:spPr>
-        <p:txBody>
-          <a:bodyPr wrap="square" anchor="ctr" lIns="36576" rIns="36576" tIns="18288" bIns="18288">
-            <a:spAutoFit/>
-          </a:bodyPr>
-          <a:lstStyle/>
-          <a:p>
-            <a:pPr algn="l">
-              <a:lnSpc>
-                <a:spcPct val="105000"/>
-              </a:lnSpc>
-            </a:pPr>
-            <a:r>
-              <a:rPr sz="1650" b="1">
-                <a:solidFill>
-                  <a:srgbClr val="17313F"/>
-                </a:solidFill>
-                <a:latin typeface="Microsoft YaHei"/>
-              </a:rPr>
-              <a:t>可解释 · 可审计</a:t>
-            </a:r>
-          </a:p>
-        </p:txBody>
-      </p:sp>
-      <p:sp>
-        <p:nvSpPr>
-          <p:cNvPr id="17" name="TextBox 16"/>
-          <p:cNvSpPr txBox="1"/>
-          <p:nvPr/>
-        </p:nvSpPr>
-        <p:spPr>
-          <a:xfrm>
-            <a:off x="859536" y="5230368"/>
-            <a:ext cx="4764024" cy="731520"/>
-          </a:xfrm>
-          <a:prstGeom prst="rect">
-            <a:avLst/>
-          </a:prstGeom>
-          <a:noFill/>
-        </p:spPr>
-        <p:txBody>
-          <a:bodyPr wrap="square" anchor="t" lIns="36576" rIns="36576" tIns="18288" bIns="18288">
-            <a:spAutoFit/>
-          </a:bodyPr>
-          <a:lstStyle/>
-          <a:p>
-            <a:pPr algn="l">
-              <a:lnSpc>
-                <a:spcPct val="118000"/>
-              </a:lnSpc>
-            </a:pPr>
-            <a:r>
-              <a:rPr sz="1250" b="0">
-                <a:solidFill>
-                  <a:srgbClr val="71838F"/>
-                </a:solidFill>
-                <a:latin typeface="Microsoft YaHei"/>
-              </a:rPr>
-              <a:t>每个告警都说得清「为什么」，分级与变更全程留痕，经得起监管追问。</a:t>
-            </a:r>
-          </a:p>
-        </p:txBody>
-      </p:sp>
-      <p:sp>
-        <p:nvSpPr>
-          <p:cNvPr id="18" name="Rounded Rectangle 17"/>
-          <p:cNvSpPr/>
-          <p:nvPr/>
-        </p:nvSpPr>
-        <p:spPr>
-          <a:xfrm>
-            <a:off x="6291072" y="4297680"/>
-            <a:ext cx="5358384" cy="1783080"/>
-          </a:xfrm>
-          <a:prstGeom prst="roundRect">
-            <a:avLst>
-              <a:gd name="adj" fmla="val 10000"/>
-            </a:avLst>
-          </a:prstGeom>
-          <a:solidFill>
-            <a:srgbClr val="F4FAFB"/>
-          </a:solidFill>
-          <a:ln w="12700">
-            <a:solidFill>
-              <a:srgbClr val="DCE8EE"/>
-            </a:solidFill>
-          </a:ln>
-          <a:effectLst/>
-        </p:spPr>
-        <p:style>
-          <a:lnRef idx="1">
-            <a:schemeClr val="accent1"/>
-          </a:lnRef>
-          <a:fillRef idx="3">
-            <a:schemeClr val="accent1"/>
-          </a:fillRef>
-          <a:effectRef idx="2">
-            <a:schemeClr val="accent1"/>
-          </a:effectRef>
-          <a:fontRef idx="minor">
-            <a:schemeClr val="lt1"/>
-          </a:fontRef>
-        </p:style>
-        <p:txBody>
-          <a:bodyPr rtlCol="0" anchor="ctr"/>
-          <a:lstStyle/>
-          <a:p>
-            <a:pPr algn="ctr"/>
-          </a:p>
-        </p:txBody>
-      </p:sp>
-      <p:sp>
-        <p:nvSpPr>
-          <p:cNvPr id="19" name="Rounded Rectangle 18"/>
-          <p:cNvSpPr/>
-          <p:nvPr/>
-        </p:nvSpPr>
-        <p:spPr>
-          <a:xfrm>
-            <a:off x="6565392" y="4590288"/>
-            <a:ext cx="566928" cy="566928"/>
-          </a:xfrm>
-          <a:prstGeom prst="roundRect">
-            <a:avLst>
-              <a:gd name="adj" fmla="val 25000"/>
-            </a:avLst>
-          </a:prstGeom>
-          <a:solidFill>
-            <a:srgbClr val="1BA39C"/>
-          </a:solidFill>
-          <a:ln>
-            <a:noFill/>
-          </a:ln>
-          <a:effectLst/>
-        </p:spPr>
-        <p:style>
-          <a:lnRef idx="1">
-            <a:schemeClr val="accent1"/>
-          </a:lnRef>
-          <a:fillRef idx="3">
-            <a:schemeClr val="accent1"/>
-          </a:fillRef>
-          <a:effectRef idx="2">
-            <a:schemeClr val="accent1"/>
-          </a:effectRef>
-          <a:fontRef idx="minor">
-            <a:schemeClr val="lt1"/>
-          </a:fontRef>
-        </p:style>
-        <p:txBody>
-          <a:bodyPr rtlCol="0" anchor="ctr" wrap="none"/>
-          <a:lstStyle/>
-          <a:p>
-            <a:pPr algn="ctr"/>
-            <a:r>
-              <a:rPr sz="2000" b="1">
-                <a:solidFill>
-                  <a:srgbClr val="FFFFFF"/>
-                </a:solidFill>
-                <a:latin typeface="Microsoft YaHei"/>
-              </a:rPr>
-              <a:t>4</a:t>
-            </a:r>
-          </a:p>
-        </p:txBody>
-      </p:sp>
-      <p:sp>
-        <p:nvSpPr>
-          <p:cNvPr id="20" name="TextBox 19"/>
-          <p:cNvSpPr txBox="1"/>
-          <p:nvPr/>
-        </p:nvSpPr>
-        <p:spPr>
-          <a:xfrm>
-            <a:off x="7315200" y="4572000"/>
-            <a:ext cx="4078224" cy="457200"/>
-          </a:xfrm>
-          <a:prstGeom prst="rect">
-            <a:avLst/>
-          </a:prstGeom>
-          <a:noFill/>
-        </p:spPr>
-        <p:txBody>
-          <a:bodyPr wrap="square" anchor="ctr" lIns="36576" rIns="36576" tIns="18288" bIns="18288">
-            <a:spAutoFit/>
-          </a:bodyPr>
-          <a:lstStyle/>
-          <a:p>
-            <a:pPr algn="l">
-              <a:lnSpc>
-                <a:spcPct val="105000"/>
-              </a:lnSpc>
-            </a:pPr>
-            <a:r>
-              <a:rPr sz="1650" b="1">
-                <a:solidFill>
-                  <a:srgbClr val="17313F"/>
-                </a:solidFill>
-                <a:latin typeface="Microsoft YaHei"/>
-              </a:rPr>
-              <a:t>越用越准 · 提效</a:t>
-            </a:r>
-          </a:p>
-        </p:txBody>
-      </p:sp>
-      <p:sp>
-        <p:nvSpPr>
-          <p:cNvPr id="21" name="TextBox 20"/>
-          <p:cNvSpPr txBox="1"/>
-          <p:nvPr/>
-        </p:nvSpPr>
-        <p:spPr>
-          <a:xfrm>
-            <a:off x="6601968" y="5230368"/>
-            <a:ext cx="4764024" cy="731520"/>
-          </a:xfrm>
-          <a:prstGeom prst="rect">
-            <a:avLst/>
-          </a:prstGeom>
-          <a:noFill/>
-        </p:spPr>
-        <p:txBody>
-          <a:bodyPr wrap="square" anchor="t" lIns="36576" rIns="36576" tIns="18288" bIns="18288">
-            <a:spAutoFit/>
-          </a:bodyPr>
-          <a:lstStyle/>
-          <a:p>
-            <a:pPr algn="l">
-              <a:lnSpc>
-                <a:spcPct val="118000"/>
-              </a:lnSpc>
-            </a:pPr>
-            <a:r>
-              <a:rPr sz="1250" b="0">
-                <a:solidFill>
-                  <a:srgbClr val="71838F"/>
-                </a:solidFill>
-                <a:latin typeface="Microsoft YaHei"/>
-              </a:rPr>
-              <a:t>AI 调查取证提效；每次复核反哺系统，识别能力持续提升。</a:t>
-            </a:r>
           </a:p>
         </p:txBody>
       </p:sp>

</xml_diff>